<commit_message>
v2: Remove ExtraBold, more blue, rounder corners, watermark, fix slide 24
- Typography: Syne Bold replaces ExtraBold (no extra bold anywhere)
- Corner rounding increased from 4% to 8% for more visible roundness
- Blue #2A3EF4 used extensively: footer bars, callout boxes, accent bars,
  number badges on light-background slides
- ISI vector watermark at 15% opacity on all cover and section divider slides
- Slide 24 (checklist): fixed element overlap by compressing card rows and
  repositioning test bar below documentation card
- Logo on slide 24 moved to bottom-right to avoid test bar conflict

https://claude.ai/code/session_015xLJ8L3G7pUWTaesG4ZzBV
</commit_message>
<xml_diff>
--- a/claude_ESG_Ready_Modulo2_ISI.pptx
+++ b/claude_ESG_Ready_Modulo2_ISI.pptx
@@ -6410,7 +6410,7 @@
           </a:xfrm>
           <a:prstGeom prst="roundRect">
             <a:avLst>
-              <a:gd name="adj" fmla="val 4000"/>
+              <a:gd name="adj" fmla="val 8000"/>
             </a:avLst>
           </a:prstGeom>
           <a:noFill/>
@@ -6443,9 +6443,9 @@
                 <a:solidFill>
                   <a:srgbClr val="FFFFFF"/>
                 </a:solidFill>
-                <a:latin typeface="Syne ExtraBold"/>
-                <a:ea typeface="Syne ExtraBold"/>
-                <a:cs typeface="Syne ExtraBold"/>
+                <a:latin typeface="Syne Bold"/>
+                <a:ea typeface="Syne Bold"/>
+                <a:cs typeface="Syne Bold"/>
                 <a:sym typeface="Arial Black"/>
               </a:rPr>
               <a:t>ESG Ready</a:t>
@@ -6621,7 +6621,7 @@
           </a:xfrm>
           <a:prstGeom prst="roundRect">
             <a:avLst>
-              <a:gd name="adj" fmla="val 4000"/>
+              <a:gd name="adj" fmla="val 8000"/>
             </a:avLst>
           </a:prstGeom>
           <a:noFill/>
@@ -6819,7 +6819,7 @@
           </a:xfrm>
           <a:prstGeom prst="roundRect">
             <a:avLst>
-              <a:gd name="adj" fmla="val 4000"/>
+              <a:gd name="adj" fmla="val 8000"/>
             </a:avLst>
           </a:prstGeom>
           <a:noFill/>
@@ -6830,14 +6830,40 @@
       </p:pic>
       <p:pic>
         <p:nvPicPr>
-          <p:cNvPr id="26" name="Picture 25" descr="LOGO ISI CLARO.png"/>
+          <p:cNvPr id="26" name="Picture 25" descr="logo_isi_WHITE.png"/>
           <p:cNvPicPr>
             <a:picLocks noChangeAspect="1"/>
           </p:cNvPicPr>
           <p:nvPr/>
         </p:nvPicPr>
         <p:blipFill>
-          <a:blip r:embed="rId4"/>
+          <a:blip r:embed="rId4">
+            <a:alphaModFix amt="15000"/>
+          </a:blip>
+          <a:stretch>
+            <a:fillRect/>
+          </a:stretch>
+        </p:blipFill>
+        <p:spPr>
+          <a:xfrm>
+            <a:off x="6126480" y="2125980"/>
+            <a:ext cx="2743200" cy="2743200"/>
+          </a:xfrm>
+          <a:prstGeom prst="rect">
+            <a:avLst/>
+          </a:prstGeom>
+        </p:spPr>
+      </p:pic>
+      <p:pic>
+        <p:nvPicPr>
+          <p:cNvPr id="27" name="Picture 26" descr="LOGO ISI CLARO.png"/>
+          <p:cNvPicPr>
+            <a:picLocks noChangeAspect="1"/>
+          </p:cNvPicPr>
+          <p:nvPr/>
+        </p:nvPicPr>
+        <p:blipFill>
+          <a:blip r:embed="rId5"/>
           <a:stretch>
             <a:fillRect/>
           </a:stretch>
@@ -6933,7 +6959,7 @@
             </a:pathLst>
           </a:custGeom>
           <a:solidFill>
-            <a:srgbClr val="150047"/>
+            <a:srgbClr val="2A3EF4"/>
           </a:solidFill>
           <a:ln>
             <a:noFill/>
@@ -7043,7 +7069,7 @@
           </a:xfrm>
           <a:prstGeom prst="roundRect">
             <a:avLst>
-              <a:gd name="adj" fmla="val 4000"/>
+              <a:gd name="adj" fmla="val 8000"/>
             </a:avLst>
           </a:prstGeom>
           <a:noFill/>
@@ -7139,9 +7165,9 @@
                 <a:solidFill>
                   <a:srgbClr val="150047"/>
                 </a:solidFill>
-                <a:latin typeface="Syne ExtraBold"/>
-                <a:ea typeface="Syne ExtraBold"/>
-                <a:cs typeface="Syne ExtraBold"/>
+                <a:latin typeface="Syne Bold"/>
+                <a:ea typeface="Syne Bold"/>
+                <a:cs typeface="Syne Bold"/>
                 <a:sym typeface="Arial Black"/>
               </a:rPr>
               <a:t>Los 3 datos básicos de energía</a:t>
@@ -7344,7 +7370,7 @@
           </a:xfrm>
           <a:prstGeom prst="roundRect">
             <a:avLst>
-              <a:gd name="adj" fmla="val 4000"/>
+              <a:gd name="adj" fmla="val 8000"/>
             </a:avLst>
           </a:prstGeom>
           <a:noFill/>
@@ -7377,9 +7403,9 @@
                 <a:solidFill>
                   <a:srgbClr val="FFFFFF"/>
                 </a:solidFill>
-                <a:latin typeface="Syne ExtraBold"/>
-                <a:ea typeface="Syne ExtraBold"/>
-                <a:cs typeface="Syne ExtraBold"/>
+                <a:latin typeface="Syne Bold"/>
+                <a:ea typeface="Syne Bold"/>
+                <a:cs typeface="Syne Bold"/>
                 <a:sym typeface="Arial Black"/>
               </a:rPr>
               <a:t>1</a:t>
@@ -7409,7 +7435,7 @@
           </a:xfrm>
           <a:prstGeom prst="roundRect">
             <a:avLst>
-              <a:gd name="adj" fmla="val 4000"/>
+              <a:gd name="adj" fmla="val 8000"/>
             </a:avLst>
           </a:prstGeom>
           <a:noFill/>
@@ -7474,7 +7500,7 @@
           </a:xfrm>
           <a:prstGeom prst="roundRect">
             <a:avLst>
-              <a:gd name="adj" fmla="val 4000"/>
+              <a:gd name="adj" fmla="val 8000"/>
             </a:avLst>
           </a:prstGeom>
           <a:noFill/>
@@ -7749,7 +7775,7 @@
           </a:xfrm>
           <a:prstGeom prst="roundRect">
             <a:avLst>
-              <a:gd name="adj" fmla="val 4000"/>
+              <a:gd name="adj" fmla="val 8000"/>
             </a:avLst>
           </a:prstGeom>
           <a:noFill/>
@@ -7782,9 +7808,9 @@
                 <a:solidFill>
                   <a:srgbClr val="FFFFFF"/>
                 </a:solidFill>
-                <a:latin typeface="Syne ExtraBold"/>
-                <a:ea typeface="Syne ExtraBold"/>
-                <a:cs typeface="Syne ExtraBold"/>
+                <a:latin typeface="Syne Bold"/>
+                <a:ea typeface="Syne Bold"/>
+                <a:cs typeface="Syne Bold"/>
                 <a:sym typeface="Arial Black"/>
               </a:rPr>
               <a:t>2</a:t>
@@ -7814,7 +7840,7 @@
           </a:xfrm>
           <a:prstGeom prst="roundRect">
             <a:avLst>
-              <a:gd name="adj" fmla="val 4000"/>
+              <a:gd name="adj" fmla="val 8000"/>
             </a:avLst>
           </a:prstGeom>
           <a:noFill/>
@@ -7879,7 +7905,7 @@
           </a:xfrm>
           <a:prstGeom prst="roundRect">
             <a:avLst>
-              <a:gd name="adj" fmla="val 4000"/>
+              <a:gd name="adj" fmla="val 8000"/>
             </a:avLst>
           </a:prstGeom>
           <a:noFill/>
@@ -8154,7 +8180,7 @@
           </a:xfrm>
           <a:prstGeom prst="roundRect">
             <a:avLst>
-              <a:gd name="adj" fmla="val 4000"/>
+              <a:gd name="adj" fmla="val 8000"/>
             </a:avLst>
           </a:prstGeom>
           <a:noFill/>
@@ -8187,9 +8213,9 @@
                 <a:solidFill>
                   <a:srgbClr val="FFFFFF"/>
                 </a:solidFill>
-                <a:latin typeface="Syne ExtraBold"/>
-                <a:ea typeface="Syne ExtraBold"/>
-                <a:cs typeface="Syne ExtraBold"/>
+                <a:latin typeface="Syne Bold"/>
+                <a:ea typeface="Syne Bold"/>
+                <a:cs typeface="Syne Bold"/>
                 <a:sym typeface="Arial Black"/>
               </a:rPr>
               <a:t>3</a:t>
@@ -8219,7 +8245,7 @@
           </a:xfrm>
           <a:prstGeom prst="roundRect">
             <a:avLst>
-              <a:gd name="adj" fmla="val 4000"/>
+              <a:gd name="adj" fmla="val 8000"/>
             </a:avLst>
           </a:prstGeom>
           <a:noFill/>
@@ -8284,7 +8310,7 @@
           </a:xfrm>
           <a:prstGeom prst="roundRect">
             <a:avLst>
-              <a:gd name="adj" fmla="val 4000"/>
+              <a:gd name="adj" fmla="val 8000"/>
             </a:avLst>
           </a:prstGeom>
           <a:noFill/>
@@ -8422,7 +8448,7 @@
             </a:pathLst>
           </a:custGeom>
           <a:solidFill>
-            <a:srgbClr val="150047"/>
+            <a:srgbClr val="2A3EF4"/>
           </a:solidFill>
           <a:ln>
             <a:noFill/>
@@ -8483,7 +8509,7 @@
           </a:xfrm>
           <a:prstGeom prst="roundRect">
             <a:avLst>
-              <a:gd name="adj" fmla="val 4000"/>
+              <a:gd name="adj" fmla="val 8000"/>
             </a:avLst>
           </a:prstGeom>
           <a:noFill/>
@@ -8660,7 +8686,7 @@
             </a:pathLst>
           </a:custGeom>
           <a:solidFill>
-            <a:srgbClr val="150047"/>
+            <a:srgbClr val="2A3EF4"/>
           </a:solidFill>
           <a:ln>
             <a:noFill/>
@@ -8770,7 +8796,7 @@
           </a:xfrm>
           <a:prstGeom prst="roundRect">
             <a:avLst>
-              <a:gd name="adj" fmla="val 4000"/>
+              <a:gd name="adj" fmla="val 8000"/>
             </a:avLst>
           </a:prstGeom>
           <a:noFill/>
@@ -8866,9 +8892,9 @@
                 <a:solidFill>
                   <a:srgbClr val="150047"/>
                 </a:solidFill>
-                <a:latin typeface="Syne ExtraBold"/>
-                <a:ea typeface="Syne ExtraBold"/>
-                <a:cs typeface="Syne ExtraBold"/>
+                <a:latin typeface="Syne Bold"/>
+                <a:ea typeface="Syne Bold"/>
+                <a:cs typeface="Syne Bold"/>
                 <a:sym typeface="Arial Black"/>
               </a:rPr>
               <a:t>Energía renovable: ¿cuenta o no?</a:t>
@@ -9024,7 +9050,7 @@
             </a:pathLst>
           </a:custGeom>
           <a:solidFill>
-            <a:srgbClr val="95EBDA"/>
+            <a:srgbClr val="2A3EF4"/>
           </a:solidFill>
           <a:ln>
             <a:noFill/>
@@ -9071,7 +9097,7 @@
           </a:xfrm>
           <a:prstGeom prst="roundRect">
             <a:avLst>
-              <a:gd name="adj" fmla="val 4000"/>
+              <a:gd name="adj" fmla="val 8000"/>
             </a:avLst>
           </a:prstGeom>
           <a:noFill/>
@@ -9136,7 +9162,7 @@
           </a:xfrm>
           <a:prstGeom prst="roundRect">
             <a:avLst>
-              <a:gd name="adj" fmla="val 4000"/>
+              <a:gd name="adj" fmla="val 8000"/>
             </a:avLst>
           </a:prstGeom>
           <a:noFill/>
@@ -9445,7 +9471,7 @@
           </a:xfrm>
           <a:prstGeom prst="roundRect">
             <a:avLst>
-              <a:gd name="adj" fmla="val 4000"/>
+              <a:gd name="adj" fmla="val 8000"/>
             </a:avLst>
           </a:prstGeom>
           <a:noFill/>
@@ -9510,7 +9536,7 @@
           </a:xfrm>
           <a:prstGeom prst="roundRect">
             <a:avLst>
-              <a:gd name="adj" fmla="val 4000"/>
+              <a:gd name="adj" fmla="val 8000"/>
             </a:avLst>
           </a:prstGeom>
           <a:noFill/>
@@ -9785,7 +9811,7 @@
           </a:xfrm>
           <a:prstGeom prst="roundRect">
             <a:avLst>
-              <a:gd name="adj" fmla="val 4000"/>
+              <a:gd name="adj" fmla="val 8000"/>
             </a:avLst>
           </a:prstGeom>
           <a:noFill/>
@@ -9818,9 +9844,9 @@
                 <a:solidFill>
                   <a:srgbClr val="95EBDA"/>
                 </a:solidFill>
-                <a:latin typeface="Syne ExtraBold"/>
-                <a:ea typeface="Syne ExtraBold"/>
-                <a:cs typeface="Syne ExtraBold"/>
+                <a:latin typeface="Syne Bold"/>
+                <a:ea typeface="Syne Bold"/>
+                <a:cs typeface="Syne Bold"/>
                 <a:sym typeface="Arial Black"/>
               </a:rPr>
               <a:t>04</a:t>
@@ -9850,7 +9876,7 @@
           </a:xfrm>
           <a:prstGeom prst="roundRect">
             <a:avLst>
-              <a:gd name="adj" fmla="val 4000"/>
+              <a:gd name="adj" fmla="val 8000"/>
             </a:avLst>
           </a:prstGeom>
           <a:noFill/>
@@ -10022,7 +10048,7 @@
           </a:xfrm>
           <a:prstGeom prst="roundRect">
             <a:avLst>
-              <a:gd name="adj" fmla="val 4000"/>
+              <a:gd name="adj" fmla="val 8000"/>
             </a:avLst>
           </a:prstGeom>
           <a:noFill/>
@@ -10033,14 +10059,40 @@
       </p:pic>
       <p:pic>
         <p:nvPicPr>
-          <p:cNvPr id="219" name="Picture 218" descr="LOGO ISI CLARO.png"/>
+          <p:cNvPr id="219" name="Picture 218" descr="logo_isi_WHITE.png"/>
           <p:cNvPicPr>
             <a:picLocks noChangeAspect="1"/>
           </p:cNvPicPr>
           <p:nvPr/>
         </p:nvPicPr>
         <p:blipFill>
-          <a:blip r:embed="rId4"/>
+          <a:blip r:embed="rId4">
+            <a:alphaModFix amt="15000"/>
+          </a:blip>
+          <a:stretch>
+            <a:fillRect/>
+          </a:stretch>
+        </p:blipFill>
+        <p:spPr>
+          <a:xfrm>
+            <a:off x="6126480" y="2125980"/>
+            <a:ext cx="2743200" cy="2743200"/>
+          </a:xfrm>
+          <a:prstGeom prst="rect">
+            <a:avLst/>
+          </a:prstGeom>
+        </p:spPr>
+      </p:pic>
+      <p:pic>
+        <p:nvPicPr>
+          <p:cNvPr id="220" name="Picture 219" descr="LOGO ISI CLARO.png"/>
+          <p:cNvPicPr>
+            <a:picLocks noChangeAspect="1"/>
+          </p:cNvPicPr>
+          <p:nvPr/>
+        </p:nvPicPr>
+        <p:blipFill>
+          <a:blip r:embed="rId5"/>
           <a:stretch>
             <a:fillRect/>
           </a:stretch>
@@ -10136,7 +10188,7 @@
             </a:pathLst>
           </a:custGeom>
           <a:solidFill>
-            <a:srgbClr val="150047"/>
+            <a:srgbClr val="2A3EF4"/>
           </a:solidFill>
           <a:ln>
             <a:noFill/>
@@ -10246,7 +10298,7 @@
           </a:xfrm>
           <a:prstGeom prst="roundRect">
             <a:avLst>
-              <a:gd name="adj" fmla="val 4000"/>
+              <a:gd name="adj" fmla="val 8000"/>
             </a:avLst>
           </a:prstGeom>
           <a:noFill/>
@@ -10342,9 +10394,9 @@
                 <a:solidFill>
                   <a:srgbClr val="150047"/>
                 </a:solidFill>
-                <a:latin typeface="Syne ExtraBold"/>
-                <a:ea typeface="Syne ExtraBold"/>
-                <a:cs typeface="Syne ExtraBold"/>
+                <a:latin typeface="Syne Bold"/>
+                <a:ea typeface="Syne Bold"/>
+                <a:cs typeface="Syne Bold"/>
                 <a:sym typeface="Arial Black"/>
               </a:rPr>
               <a:t>¿Qué te van a pedir?</a:t>
@@ -10500,7 +10552,7 @@
             </a:pathLst>
           </a:custGeom>
           <a:solidFill>
-            <a:srgbClr val="95EBDA"/>
+            <a:srgbClr val="2A3EF4"/>
           </a:solidFill>
           <a:ln>
             <a:noFill/>
@@ -10547,11 +10599,11 @@
           </a:xfrm>
           <a:prstGeom prst="roundRect">
             <a:avLst>
-              <a:gd name="adj" fmla="val 4000"/>
+              <a:gd name="adj" fmla="val 8000"/>
             </a:avLst>
           </a:prstGeom>
           <a:solidFill>
-            <a:srgbClr val="150047"/>
+            <a:srgbClr val="2A3EF4"/>
           </a:solidFill>
           <a:ln>
             <a:noFill/>
@@ -10598,7 +10650,7 @@
           </a:xfrm>
           <a:prstGeom prst="roundRect">
             <a:avLst>
-              <a:gd name="adj" fmla="val 4000"/>
+              <a:gd name="adj" fmla="val 8000"/>
             </a:avLst>
           </a:prstGeom>
           <a:noFill/>
@@ -10631,9 +10683,9 @@
                 <a:solidFill>
                   <a:srgbClr val="95EBDA"/>
                 </a:solidFill>
-                <a:latin typeface="Syne ExtraBold"/>
-                <a:ea typeface="Syne ExtraBold"/>
-                <a:cs typeface="Syne ExtraBold"/>
+                <a:latin typeface="Syne Bold"/>
+                <a:ea typeface="Syne Bold"/>
+                <a:cs typeface="Syne Bold"/>
                 <a:sym typeface="Arial Black"/>
               </a:rPr>
               <a:t>1</a:t>
@@ -10915,7 +10967,7 @@
             </a:pathLst>
           </a:custGeom>
           <a:solidFill>
-            <a:srgbClr val="95EBDA"/>
+            <a:srgbClr val="2A3EF4"/>
           </a:solidFill>
           <a:ln>
             <a:noFill/>
@@ -10962,11 +11014,11 @@
           </a:xfrm>
           <a:prstGeom prst="roundRect">
             <a:avLst>
-              <a:gd name="adj" fmla="val 4000"/>
+              <a:gd name="adj" fmla="val 8000"/>
             </a:avLst>
           </a:prstGeom>
           <a:solidFill>
-            <a:srgbClr val="150047"/>
+            <a:srgbClr val="2A3EF4"/>
           </a:solidFill>
           <a:ln>
             <a:noFill/>
@@ -11013,7 +11065,7 @@
           </a:xfrm>
           <a:prstGeom prst="roundRect">
             <a:avLst>
-              <a:gd name="adj" fmla="val 4000"/>
+              <a:gd name="adj" fmla="val 8000"/>
             </a:avLst>
           </a:prstGeom>
           <a:noFill/>
@@ -11046,9 +11098,9 @@
                 <a:solidFill>
                   <a:srgbClr val="95EBDA"/>
                 </a:solidFill>
-                <a:latin typeface="Syne ExtraBold"/>
-                <a:ea typeface="Syne ExtraBold"/>
-                <a:cs typeface="Syne ExtraBold"/>
+                <a:latin typeface="Syne Bold"/>
+                <a:ea typeface="Syne Bold"/>
+                <a:cs typeface="Syne Bold"/>
                 <a:sym typeface="Arial Black"/>
               </a:rPr>
               <a:t>2</a:t>
@@ -11330,7 +11382,7 @@
             </a:pathLst>
           </a:custGeom>
           <a:solidFill>
-            <a:srgbClr val="95EBDA"/>
+            <a:srgbClr val="2A3EF4"/>
           </a:solidFill>
           <a:ln>
             <a:noFill/>
@@ -11377,11 +11429,11 @@
           </a:xfrm>
           <a:prstGeom prst="roundRect">
             <a:avLst>
-              <a:gd name="adj" fmla="val 4000"/>
+              <a:gd name="adj" fmla="val 8000"/>
             </a:avLst>
           </a:prstGeom>
           <a:solidFill>
-            <a:srgbClr val="150047"/>
+            <a:srgbClr val="2A3EF4"/>
           </a:solidFill>
           <a:ln>
             <a:noFill/>
@@ -11428,7 +11480,7 @@
           </a:xfrm>
           <a:prstGeom prst="roundRect">
             <a:avLst>
-              <a:gd name="adj" fmla="val 4000"/>
+              <a:gd name="adj" fmla="val 8000"/>
             </a:avLst>
           </a:prstGeom>
           <a:noFill/>
@@ -11461,9 +11513,9 @@
                 <a:solidFill>
                   <a:srgbClr val="95EBDA"/>
                 </a:solidFill>
-                <a:latin typeface="Syne ExtraBold"/>
-                <a:ea typeface="Syne ExtraBold"/>
-                <a:cs typeface="Syne ExtraBold"/>
+                <a:latin typeface="Syne Bold"/>
+                <a:ea typeface="Syne Bold"/>
+                <a:cs typeface="Syne Bold"/>
                 <a:sym typeface="Arial Black"/>
               </a:rPr>
               <a:t>3</a:t>
@@ -11792,7 +11844,7 @@
           </a:xfrm>
           <a:prstGeom prst="roundRect">
             <a:avLst>
-              <a:gd name="adj" fmla="val 4000"/>
+              <a:gd name="adj" fmla="val 8000"/>
             </a:avLst>
           </a:prstGeom>
           <a:noFill/>
@@ -12019,7 +12071,7 @@
           </a:xfrm>
           <a:prstGeom prst="roundRect">
             <a:avLst>
-              <a:gd name="adj" fmla="val 4000"/>
+              <a:gd name="adj" fmla="val 8000"/>
             </a:avLst>
           </a:prstGeom>
           <a:noFill/>
@@ -12052,9 +12104,9 @@
                 <a:solidFill>
                   <a:srgbClr val="95EBDA"/>
                 </a:solidFill>
-                <a:latin typeface="Syne ExtraBold"/>
-                <a:ea typeface="Syne ExtraBold"/>
-                <a:cs typeface="Syne ExtraBold"/>
+                <a:latin typeface="Syne Bold"/>
+                <a:ea typeface="Syne Bold"/>
+                <a:cs typeface="Syne Bold"/>
                 <a:sym typeface="Arial Black"/>
               </a:rPr>
               <a:t>05</a:t>
@@ -12084,7 +12136,7 @@
           </a:xfrm>
           <a:prstGeom prst="roundRect">
             <a:avLst>
-              <a:gd name="adj" fmla="val 4000"/>
+              <a:gd name="adj" fmla="val 8000"/>
             </a:avLst>
           </a:prstGeom>
           <a:noFill/>
@@ -12256,7 +12308,7 @@
           </a:xfrm>
           <a:prstGeom prst="roundRect">
             <a:avLst>
-              <a:gd name="adj" fmla="val 4000"/>
+              <a:gd name="adj" fmla="val 8000"/>
             </a:avLst>
           </a:prstGeom>
           <a:noFill/>
@@ -12267,14 +12319,40 @@
       </p:pic>
       <p:pic>
         <p:nvPicPr>
-          <p:cNvPr id="260" name="Picture 259" descr="LOGO ISI CLARO.png"/>
+          <p:cNvPr id="260" name="Picture 259" descr="logo_isi_WHITE.png"/>
           <p:cNvPicPr>
             <a:picLocks noChangeAspect="1"/>
           </p:cNvPicPr>
           <p:nvPr/>
         </p:nvPicPr>
         <p:blipFill>
-          <a:blip r:embed="rId4"/>
+          <a:blip r:embed="rId4">
+            <a:alphaModFix amt="15000"/>
+          </a:blip>
+          <a:stretch>
+            <a:fillRect/>
+          </a:stretch>
+        </p:blipFill>
+        <p:spPr>
+          <a:xfrm>
+            <a:off x="6126480" y="2125980"/>
+            <a:ext cx="2743200" cy="2743200"/>
+          </a:xfrm>
+          <a:prstGeom prst="rect">
+            <a:avLst/>
+          </a:prstGeom>
+        </p:spPr>
+      </p:pic>
+      <p:pic>
+        <p:nvPicPr>
+          <p:cNvPr id="261" name="Picture 260" descr="LOGO ISI CLARO.png"/>
+          <p:cNvPicPr>
+            <a:picLocks noChangeAspect="1"/>
+          </p:cNvPicPr>
+          <p:nvPr/>
+        </p:nvPicPr>
+        <p:blipFill>
+          <a:blip r:embed="rId5"/>
           <a:stretch>
             <a:fillRect/>
           </a:stretch>
@@ -12370,7 +12448,7 @@
             </a:pathLst>
           </a:custGeom>
           <a:solidFill>
-            <a:srgbClr val="150047"/>
+            <a:srgbClr val="2A3EF4"/>
           </a:solidFill>
           <a:ln>
             <a:noFill/>
@@ -12480,7 +12558,7 @@
           </a:xfrm>
           <a:prstGeom prst="roundRect">
             <a:avLst>
-              <a:gd name="adj" fmla="val 4000"/>
+              <a:gd name="adj" fmla="val 8000"/>
             </a:avLst>
           </a:prstGeom>
           <a:noFill/>
@@ -12576,9 +12654,9 @@
                 <a:solidFill>
                   <a:srgbClr val="150047"/>
                 </a:solidFill>
-                <a:latin typeface="Syne ExtraBold"/>
-                <a:ea typeface="Syne ExtraBold"/>
-                <a:cs typeface="Syne ExtraBold"/>
+                <a:latin typeface="Syne Bold"/>
+                <a:ea typeface="Syne Bold"/>
+                <a:cs typeface="Syne Bold"/>
                 <a:sym typeface="Arial Black"/>
               </a:rPr>
               <a:t>¿Cuándo el agua es material?</a:t>
@@ -12671,7 +12749,7 @@
           </a:xfrm>
           <a:prstGeom prst="roundRect">
             <a:avLst>
-              <a:gd name="adj" fmla="val 4000"/>
+              <a:gd name="adj" fmla="val 8000"/>
             </a:avLst>
           </a:prstGeom>
           <a:solidFill>
@@ -12765,7 +12843,7 @@
             </a:pathLst>
           </a:custGeom>
           <a:solidFill>
-            <a:srgbClr val="95EBDA"/>
+            <a:srgbClr val="2A3EF4"/>
           </a:solidFill>
           <a:ln>
             <a:noFill/>
@@ -12819,7 +12897,7 @@
           </a:xfrm>
           <a:prstGeom prst="roundRect">
             <a:avLst>
-              <a:gd name="adj" fmla="val 4000"/>
+              <a:gd name="adj" fmla="val 8000"/>
             </a:avLst>
           </a:prstGeom>
           <a:noFill/>
@@ -12841,7 +12919,7 @@
           </a:xfrm>
           <a:prstGeom prst="roundRect">
             <a:avLst>
-              <a:gd name="adj" fmla="val 4000"/>
+              <a:gd name="adj" fmla="val 8000"/>
             </a:avLst>
           </a:prstGeom>
           <a:noFill/>
@@ -12906,7 +12984,7 @@
           </a:xfrm>
           <a:prstGeom prst="roundRect">
             <a:avLst>
-              <a:gd name="adj" fmla="val 4000"/>
+              <a:gd name="adj" fmla="val 8000"/>
             </a:avLst>
           </a:prstGeom>
           <a:noFill/>
@@ -12971,7 +13049,7 @@
           </a:xfrm>
           <a:prstGeom prst="roundRect">
             <a:avLst>
-              <a:gd name="adj" fmla="val 4000"/>
+              <a:gd name="adj" fmla="val 8000"/>
             </a:avLst>
           </a:prstGeom>
           <a:solidFill>
@@ -13065,7 +13143,7 @@
             </a:pathLst>
           </a:custGeom>
           <a:solidFill>
-            <a:srgbClr val="95EBDA"/>
+            <a:srgbClr val="2A3EF4"/>
           </a:solidFill>
           <a:ln>
             <a:noFill/>
@@ -13119,7 +13197,7 @@
           </a:xfrm>
           <a:prstGeom prst="roundRect">
             <a:avLst>
-              <a:gd name="adj" fmla="val 4000"/>
+              <a:gd name="adj" fmla="val 8000"/>
             </a:avLst>
           </a:prstGeom>
           <a:noFill/>
@@ -13141,7 +13219,7 @@
           </a:xfrm>
           <a:prstGeom prst="roundRect">
             <a:avLst>
-              <a:gd name="adj" fmla="val 4000"/>
+              <a:gd name="adj" fmla="val 8000"/>
             </a:avLst>
           </a:prstGeom>
           <a:noFill/>
@@ -13206,7 +13284,7 @@
           </a:xfrm>
           <a:prstGeom prst="roundRect">
             <a:avLst>
-              <a:gd name="adj" fmla="val 4000"/>
+              <a:gd name="adj" fmla="val 8000"/>
             </a:avLst>
           </a:prstGeom>
           <a:noFill/>
@@ -13271,7 +13349,7 @@
           </a:xfrm>
           <a:prstGeom prst="roundRect">
             <a:avLst>
-              <a:gd name="adj" fmla="val 4000"/>
+              <a:gd name="adj" fmla="val 8000"/>
             </a:avLst>
           </a:prstGeom>
           <a:solidFill>
@@ -13365,7 +13443,7 @@
             </a:pathLst>
           </a:custGeom>
           <a:solidFill>
-            <a:srgbClr val="95EBDA"/>
+            <a:srgbClr val="2A3EF4"/>
           </a:solidFill>
           <a:ln>
             <a:noFill/>
@@ -13419,7 +13497,7 @@
           </a:xfrm>
           <a:prstGeom prst="roundRect">
             <a:avLst>
-              <a:gd name="adj" fmla="val 4000"/>
+              <a:gd name="adj" fmla="val 8000"/>
             </a:avLst>
           </a:prstGeom>
           <a:noFill/>
@@ -13441,7 +13519,7 @@
           </a:xfrm>
           <a:prstGeom prst="roundRect">
             <a:avLst>
-              <a:gd name="adj" fmla="val 4000"/>
+              <a:gd name="adj" fmla="val 8000"/>
             </a:avLst>
           </a:prstGeom>
           <a:noFill/>
@@ -13506,7 +13584,7 @@
           </a:xfrm>
           <a:prstGeom prst="roundRect">
             <a:avLst>
-              <a:gd name="adj" fmla="val 4000"/>
+              <a:gd name="adj" fmla="val 8000"/>
             </a:avLst>
           </a:prstGeom>
           <a:noFill/>
@@ -13571,7 +13649,7 @@
           </a:xfrm>
           <a:prstGeom prst="roundRect">
             <a:avLst>
-              <a:gd name="adj" fmla="val 4000"/>
+              <a:gd name="adj" fmla="val 8000"/>
             </a:avLst>
           </a:prstGeom>
           <a:solidFill>
@@ -13665,7 +13743,7 @@
             </a:pathLst>
           </a:custGeom>
           <a:solidFill>
-            <a:srgbClr val="95EBDA"/>
+            <a:srgbClr val="2A3EF4"/>
           </a:solidFill>
           <a:ln>
             <a:noFill/>
@@ -13719,7 +13797,7 @@
           </a:xfrm>
           <a:prstGeom prst="roundRect">
             <a:avLst>
-              <a:gd name="adj" fmla="val 4000"/>
+              <a:gd name="adj" fmla="val 8000"/>
             </a:avLst>
           </a:prstGeom>
           <a:noFill/>
@@ -13741,7 +13819,7 @@
           </a:xfrm>
           <a:prstGeom prst="roundRect">
             <a:avLst>
-              <a:gd name="adj" fmla="val 4000"/>
+              <a:gd name="adj" fmla="val 8000"/>
             </a:avLst>
           </a:prstGeom>
           <a:noFill/>
@@ -13806,7 +13884,7 @@
           </a:xfrm>
           <a:prstGeom prst="roundRect">
             <a:avLst>
-              <a:gd name="adj" fmla="val 4000"/>
+              <a:gd name="adj" fmla="val 8000"/>
             </a:avLst>
           </a:prstGeom>
           <a:noFill/>
@@ -13907,7 +13985,7 @@
             </a:pathLst>
           </a:custGeom>
           <a:solidFill>
-            <a:srgbClr val="150047"/>
+            <a:srgbClr val="2A3EF4"/>
           </a:solidFill>
           <a:ln>
             <a:noFill/>
@@ -14156,7 +14234,7 @@
           </a:xfrm>
           <a:prstGeom prst="roundRect">
             <a:avLst>
-              <a:gd name="adj" fmla="val 4000"/>
+              <a:gd name="adj" fmla="val 8000"/>
             </a:avLst>
           </a:prstGeom>
           <a:noFill/>
@@ -14189,9 +14267,9 @@
                 <a:solidFill>
                   <a:srgbClr val="95EBDA"/>
                 </a:solidFill>
-                <a:latin typeface="Syne ExtraBold"/>
-                <a:ea typeface="Syne ExtraBold"/>
-                <a:cs typeface="Syne ExtraBold"/>
+                <a:latin typeface="Syne Bold"/>
+                <a:ea typeface="Syne Bold"/>
+                <a:cs typeface="Syne Bold"/>
                 <a:sym typeface="Arial Black"/>
               </a:rPr>
               <a:t>06</a:t>
@@ -14221,7 +14299,7 @@
           </a:xfrm>
           <a:prstGeom prst="roundRect">
             <a:avLst>
-              <a:gd name="adj" fmla="val 4000"/>
+              <a:gd name="adj" fmla="val 8000"/>
             </a:avLst>
           </a:prstGeom>
           <a:noFill/>
@@ -14393,7 +14471,7 @@
           </a:xfrm>
           <a:prstGeom prst="roundRect">
             <a:avLst>
-              <a:gd name="adj" fmla="val 4000"/>
+              <a:gd name="adj" fmla="val 8000"/>
             </a:avLst>
           </a:prstGeom>
           <a:noFill/>
@@ -14404,14 +14482,40 @@
       </p:pic>
       <p:pic>
         <p:nvPicPr>
-          <p:cNvPr id="302" name="Picture 301" descr="LOGO ISI CLARO.png"/>
+          <p:cNvPr id="302" name="Picture 301" descr="logo_isi_WHITE.png"/>
           <p:cNvPicPr>
             <a:picLocks noChangeAspect="1"/>
           </p:cNvPicPr>
           <p:nvPr/>
         </p:nvPicPr>
         <p:blipFill>
-          <a:blip r:embed="rId4"/>
+          <a:blip r:embed="rId4">
+            <a:alphaModFix amt="15000"/>
+          </a:blip>
+          <a:stretch>
+            <a:fillRect/>
+          </a:stretch>
+        </p:blipFill>
+        <p:spPr>
+          <a:xfrm>
+            <a:off x="6126480" y="2125980"/>
+            <a:ext cx="2743200" cy="2743200"/>
+          </a:xfrm>
+          <a:prstGeom prst="rect">
+            <a:avLst/>
+          </a:prstGeom>
+        </p:spPr>
+      </p:pic>
+      <p:pic>
+        <p:nvPicPr>
+          <p:cNvPr id="303" name="Picture 302" descr="LOGO ISI CLARO.png"/>
+          <p:cNvPicPr>
+            <a:picLocks noChangeAspect="1"/>
+          </p:cNvPicPr>
+          <p:nvPr/>
+        </p:nvPicPr>
+        <p:blipFill>
+          <a:blip r:embed="rId5"/>
           <a:stretch>
             <a:fillRect/>
           </a:stretch>
@@ -14507,7 +14611,7 @@
             </a:pathLst>
           </a:custGeom>
           <a:solidFill>
-            <a:srgbClr val="150047"/>
+            <a:srgbClr val="2A3EF4"/>
           </a:solidFill>
           <a:ln>
             <a:noFill/>
@@ -14617,7 +14721,7 @@
           </a:xfrm>
           <a:prstGeom prst="roundRect">
             <a:avLst>
-              <a:gd name="adj" fmla="val 4000"/>
+              <a:gd name="adj" fmla="val 8000"/>
             </a:avLst>
           </a:prstGeom>
           <a:noFill/>
@@ -14713,9 +14817,9 @@
                 <a:solidFill>
                   <a:srgbClr val="150047"/>
                 </a:solidFill>
-                <a:latin typeface="Syne ExtraBold"/>
-                <a:ea typeface="Syne ExtraBold"/>
-                <a:cs typeface="Syne ExtraBold"/>
+                <a:latin typeface="Syne Bold"/>
+                <a:ea typeface="Syne Bold"/>
+                <a:cs typeface="Syne Bold"/>
                 <a:sym typeface="Arial Black"/>
               </a:rPr>
               <a:t>Los tres alcances</a:t>
@@ -14745,7 +14849,7 @@
           </a:xfrm>
           <a:prstGeom prst="roundRect">
             <a:avLst>
-              <a:gd name="adj" fmla="val 4000"/>
+              <a:gd name="adj" fmla="val 8000"/>
             </a:avLst>
           </a:prstGeom>
           <a:solidFill>
@@ -14886,7 +14990,7 @@
           </a:xfrm>
           <a:prstGeom prst="roundRect">
             <a:avLst>
-              <a:gd name="adj" fmla="val 4000"/>
+              <a:gd name="adj" fmla="val 8000"/>
             </a:avLst>
           </a:prstGeom>
           <a:noFill/>
@@ -14919,9 +15023,9 @@
                 <a:solidFill>
                   <a:srgbClr val="150047"/>
                 </a:solidFill>
-                <a:latin typeface="Syne ExtraBold"/>
-                <a:ea typeface="Syne ExtraBold"/>
-                <a:cs typeface="Syne ExtraBold"/>
+                <a:latin typeface="Syne Bold"/>
+                <a:ea typeface="Syne Bold"/>
+                <a:cs typeface="Syne Bold"/>
                 <a:sym typeface="Arial Black"/>
               </a:rPr>
               <a:t>~10%</a:t>
@@ -14951,7 +15055,7 @@
           </a:xfrm>
           <a:prstGeom prst="roundRect">
             <a:avLst>
-              <a:gd name="adj" fmla="val 4000"/>
+              <a:gd name="adj" fmla="val 8000"/>
             </a:avLst>
           </a:prstGeom>
           <a:noFill/>
@@ -15016,7 +15120,7 @@
           </a:xfrm>
           <a:prstGeom prst="roundRect">
             <a:avLst>
-              <a:gd name="adj" fmla="val 4000"/>
+              <a:gd name="adj" fmla="val 8000"/>
             </a:avLst>
           </a:prstGeom>
           <a:noFill/>
@@ -15081,7 +15185,7 @@
           </a:xfrm>
           <a:prstGeom prst="roundRect">
             <a:avLst>
-              <a:gd name="adj" fmla="val 4000"/>
+              <a:gd name="adj" fmla="val 8000"/>
             </a:avLst>
           </a:prstGeom>
           <a:noFill/>
@@ -15146,7 +15250,7 @@
           </a:xfrm>
           <a:prstGeom prst="roundRect">
             <a:avLst>
-              <a:gd name="adj" fmla="val 4000"/>
+              <a:gd name="adj" fmla="val 8000"/>
             </a:avLst>
           </a:prstGeom>
           <a:noFill/>
@@ -15211,7 +15315,7 @@
           </a:xfrm>
           <a:prstGeom prst="roundRect">
             <a:avLst>
-              <a:gd name="adj" fmla="val 4000"/>
+              <a:gd name="adj" fmla="val 8000"/>
             </a:avLst>
           </a:prstGeom>
           <a:solidFill>
@@ -15352,7 +15456,7 @@
           </a:xfrm>
           <a:prstGeom prst="roundRect">
             <a:avLst>
-              <a:gd name="adj" fmla="val 4000"/>
+              <a:gd name="adj" fmla="val 8000"/>
             </a:avLst>
           </a:prstGeom>
           <a:noFill/>
@@ -15385,9 +15489,9 @@
                 <a:solidFill>
                   <a:srgbClr val="FFFFFF"/>
                 </a:solidFill>
-                <a:latin typeface="Syne ExtraBold"/>
-                <a:ea typeface="Syne ExtraBold"/>
-                <a:cs typeface="Syne ExtraBold"/>
+                <a:latin typeface="Syne Bold"/>
+                <a:ea typeface="Syne Bold"/>
+                <a:cs typeface="Syne Bold"/>
                 <a:sym typeface="Arial Black"/>
               </a:rPr>
               <a:t>~15%</a:t>
@@ -15417,7 +15521,7 @@
           </a:xfrm>
           <a:prstGeom prst="roundRect">
             <a:avLst>
-              <a:gd name="adj" fmla="val 4000"/>
+              <a:gd name="adj" fmla="val 8000"/>
             </a:avLst>
           </a:prstGeom>
           <a:noFill/>
@@ -15482,7 +15586,7 @@
           </a:xfrm>
           <a:prstGeom prst="roundRect">
             <a:avLst>
-              <a:gd name="adj" fmla="val 4000"/>
+              <a:gd name="adj" fmla="val 8000"/>
             </a:avLst>
           </a:prstGeom>
           <a:noFill/>
@@ -15547,7 +15651,7 @@
           </a:xfrm>
           <a:prstGeom prst="roundRect">
             <a:avLst>
-              <a:gd name="adj" fmla="val 4000"/>
+              <a:gd name="adj" fmla="val 8000"/>
             </a:avLst>
           </a:prstGeom>
           <a:noFill/>
@@ -15612,7 +15716,7 @@
           </a:xfrm>
           <a:prstGeom prst="roundRect">
             <a:avLst>
-              <a:gd name="adj" fmla="val 4000"/>
+              <a:gd name="adj" fmla="val 8000"/>
             </a:avLst>
           </a:prstGeom>
           <a:noFill/>
@@ -15677,7 +15781,7 @@
           </a:xfrm>
           <a:prstGeom prst="roundRect">
             <a:avLst>
-              <a:gd name="adj" fmla="val 4000"/>
+              <a:gd name="adj" fmla="val 8000"/>
             </a:avLst>
           </a:prstGeom>
           <a:solidFill>
@@ -15818,7 +15922,7 @@
           </a:xfrm>
           <a:prstGeom prst="roundRect">
             <a:avLst>
-              <a:gd name="adj" fmla="val 4000"/>
+              <a:gd name="adj" fmla="val 8000"/>
             </a:avLst>
           </a:prstGeom>
           <a:noFill/>
@@ -15851,9 +15955,9 @@
                 <a:solidFill>
                   <a:srgbClr val="150047"/>
                 </a:solidFill>
-                <a:latin typeface="Syne ExtraBold"/>
-                <a:ea typeface="Syne ExtraBold"/>
-                <a:cs typeface="Syne ExtraBold"/>
+                <a:latin typeface="Syne Bold"/>
+                <a:ea typeface="Syne Bold"/>
+                <a:cs typeface="Syne Bold"/>
                 <a:sym typeface="Arial Black"/>
               </a:rPr>
               <a:t>~75%</a:t>
@@ -15883,7 +15987,7 @@
           </a:xfrm>
           <a:prstGeom prst="roundRect">
             <a:avLst>
-              <a:gd name="adj" fmla="val 4000"/>
+              <a:gd name="adj" fmla="val 8000"/>
             </a:avLst>
           </a:prstGeom>
           <a:noFill/>
@@ -15948,7 +16052,7 @@
           </a:xfrm>
           <a:prstGeom prst="roundRect">
             <a:avLst>
-              <a:gd name="adj" fmla="val 4000"/>
+              <a:gd name="adj" fmla="val 8000"/>
             </a:avLst>
           </a:prstGeom>
           <a:noFill/>
@@ -16013,7 +16117,7 @@
           </a:xfrm>
           <a:prstGeom prst="roundRect">
             <a:avLst>
-              <a:gd name="adj" fmla="val 4000"/>
+              <a:gd name="adj" fmla="val 8000"/>
             </a:avLst>
           </a:prstGeom>
           <a:noFill/>
@@ -16078,7 +16182,7 @@
           </a:xfrm>
           <a:prstGeom prst="roundRect">
             <a:avLst>
-              <a:gd name="adj" fmla="val 4000"/>
+              <a:gd name="adj" fmla="val 8000"/>
             </a:avLst>
           </a:prstGeom>
           <a:noFill/>
@@ -16235,7 +16339,7 @@
             </a:pathLst>
           </a:custGeom>
           <a:solidFill>
-            <a:srgbClr val="150047"/>
+            <a:srgbClr val="2A3EF4"/>
           </a:solidFill>
           <a:ln>
             <a:noFill/>
@@ -16345,7 +16449,7 @@
           </a:xfrm>
           <a:prstGeom prst="roundRect">
             <a:avLst>
-              <a:gd name="adj" fmla="val 4000"/>
+              <a:gd name="adj" fmla="val 8000"/>
             </a:avLst>
           </a:prstGeom>
           <a:noFill/>
@@ -16441,9 +16545,9 @@
                 <a:solidFill>
                   <a:srgbClr val="150047"/>
                 </a:solidFill>
-                <a:latin typeface="Syne ExtraBold"/>
-                <a:ea typeface="Syne ExtraBold"/>
-                <a:cs typeface="Syne ExtraBold"/>
+                <a:latin typeface="Syne Bold"/>
+                <a:ea typeface="Syne Bold"/>
+                <a:cs typeface="Syne Bold"/>
                 <a:sym typeface="Arial Black"/>
               </a:rPr>
               <a:t>La fórmula es simple</a:t>
@@ -16473,11 +16577,11 @@
           </a:xfrm>
           <a:prstGeom prst="roundRect">
             <a:avLst>
-              <a:gd name="adj" fmla="val 4000"/>
+              <a:gd name="adj" fmla="val 8000"/>
             </a:avLst>
           </a:prstGeom>
           <a:solidFill>
-            <a:srgbClr val="150047"/>
+            <a:srgbClr val="2A3EF4"/>
           </a:solidFill>
           <a:ln>
             <a:noFill/>
@@ -16531,7 +16635,7 @@
           </a:xfrm>
           <a:prstGeom prst="roundRect">
             <a:avLst>
-              <a:gd name="adj" fmla="val 4000"/>
+              <a:gd name="adj" fmla="val 8000"/>
             </a:avLst>
           </a:prstGeom>
           <a:noFill/>
@@ -16596,7 +16700,7 @@
           </a:xfrm>
           <a:prstGeom prst="roundRect">
             <a:avLst>
-              <a:gd name="adj" fmla="val 4000"/>
+              <a:gd name="adj" fmla="val 8000"/>
             </a:avLst>
           </a:prstGeom>
           <a:solidFill>
@@ -16800,7 +16904,7 @@
           </a:xfrm>
           <a:prstGeom prst="roundRect">
             <a:avLst>
-              <a:gd name="adj" fmla="val 4000"/>
+              <a:gd name="adj" fmla="val 8000"/>
             </a:avLst>
           </a:prstGeom>
           <a:noFill/>
@@ -16902,7 +17006,7 @@
           </a:xfrm>
           <a:prstGeom prst="roundRect">
             <a:avLst>
-              <a:gd name="adj" fmla="val 4000"/>
+              <a:gd name="adj" fmla="val 8000"/>
             </a:avLst>
           </a:prstGeom>
           <a:solidFill>
@@ -17106,7 +17210,7 @@
           </a:xfrm>
           <a:prstGeom prst="roundRect">
             <a:avLst>
-              <a:gd name="adj" fmla="val 4000"/>
+              <a:gd name="adj" fmla="val 8000"/>
             </a:avLst>
           </a:prstGeom>
           <a:noFill/>
@@ -17347,7 +17451,7 @@
           </a:xfrm>
           <a:prstGeom prst="roundRect">
             <a:avLst>
-              <a:gd name="adj" fmla="val 4000"/>
+              <a:gd name="adj" fmla="val 8000"/>
             </a:avLst>
           </a:prstGeom>
           <a:noFill/>
@@ -17380,9 +17484,9 @@
                 <a:solidFill>
                   <a:srgbClr val="95EBDA"/>
                 </a:solidFill>
-                <a:latin typeface="Syne ExtraBold"/>
-                <a:ea typeface="Syne ExtraBold"/>
-                <a:cs typeface="Syne ExtraBold"/>
+                <a:latin typeface="Syne Bold"/>
+                <a:ea typeface="Syne Bold"/>
+                <a:cs typeface="Syne Bold"/>
                 <a:sym typeface="Arial Black"/>
               </a:rPr>
               <a:t>07</a:t>
@@ -17412,7 +17516,7 @@
           </a:xfrm>
           <a:prstGeom prst="roundRect">
             <a:avLst>
-              <a:gd name="adj" fmla="val 4000"/>
+              <a:gd name="adj" fmla="val 8000"/>
             </a:avLst>
           </a:prstGeom>
           <a:noFill/>
@@ -17621,7 +17725,7 @@
           </a:xfrm>
           <a:prstGeom prst="roundRect">
             <a:avLst>
-              <a:gd name="adj" fmla="val 4000"/>
+              <a:gd name="adj" fmla="val 8000"/>
             </a:avLst>
           </a:prstGeom>
           <a:noFill/>
@@ -17632,14 +17736,40 @@
       </p:pic>
       <p:pic>
         <p:nvPicPr>
-          <p:cNvPr id="361" name="Picture 360" descr="LOGO ISI CLARO.png"/>
+          <p:cNvPr id="361" name="Picture 360" descr="logo_isi_WHITE.png"/>
           <p:cNvPicPr>
             <a:picLocks noChangeAspect="1"/>
           </p:cNvPicPr>
           <p:nvPr/>
         </p:nvPicPr>
         <p:blipFill>
-          <a:blip r:embed="rId4"/>
+          <a:blip r:embed="rId4">
+            <a:alphaModFix amt="15000"/>
+          </a:blip>
+          <a:stretch>
+            <a:fillRect/>
+          </a:stretch>
+        </p:blipFill>
+        <p:spPr>
+          <a:xfrm>
+            <a:off x="6126480" y="2125980"/>
+            <a:ext cx="2743200" cy="2743200"/>
+          </a:xfrm>
+          <a:prstGeom prst="rect">
+            <a:avLst/>
+          </a:prstGeom>
+        </p:spPr>
+      </p:pic>
+      <p:pic>
+        <p:nvPicPr>
+          <p:cNvPr id="362" name="Picture 361" descr="LOGO ISI CLARO.png"/>
+          <p:cNvPicPr>
+            <a:picLocks noChangeAspect="1"/>
+          </p:cNvPicPr>
+          <p:nvPr/>
+        </p:nvPicPr>
+        <p:blipFill>
+          <a:blip r:embed="rId5"/>
           <a:stretch>
             <a:fillRect/>
           </a:stretch>
@@ -17730,9 +17860,9 @@
                 <a:solidFill>
                   <a:srgbClr val="150047"/>
                 </a:solidFill>
-                <a:latin typeface="Syne ExtraBold"/>
-                <a:ea typeface="Syne ExtraBold"/>
-                <a:cs typeface="Syne ExtraBold"/>
+                <a:latin typeface="Syne Bold"/>
+                <a:ea typeface="Syne Bold"/>
+                <a:cs typeface="Syne Bold"/>
                 <a:sym typeface="Arial Black"/>
               </a:rPr>
               <a:t>9 píldoras, un mapa claro</a:t>
@@ -17798,7 +17928,7 @@
             </a:pathLst>
           </a:custGeom>
           <a:solidFill>
-            <a:srgbClr val="95EBDA"/>
+            <a:srgbClr val="2A3EF4"/>
           </a:solidFill>
           <a:ln>
             <a:noFill/>
@@ -17852,7 +17982,7 @@
           </a:xfrm>
           <a:prstGeom prst="roundRect">
             <a:avLst>
-              <a:gd name="adj" fmla="val 4000"/>
+              <a:gd name="adj" fmla="val 8000"/>
             </a:avLst>
           </a:prstGeom>
           <a:noFill/>
@@ -17956,7 +18086,7 @@
           </a:xfrm>
           <a:prstGeom prst="roundRect">
             <a:avLst>
-              <a:gd name="adj" fmla="val 4000"/>
+              <a:gd name="adj" fmla="val 8000"/>
             </a:avLst>
           </a:prstGeom>
           <a:noFill/>
@@ -18060,7 +18190,7 @@
           </a:xfrm>
           <a:prstGeom prst="roundRect">
             <a:avLst>
-              <a:gd name="adj" fmla="val 4000"/>
+              <a:gd name="adj" fmla="val 8000"/>
             </a:avLst>
           </a:prstGeom>
           <a:noFill/>
@@ -18164,7 +18294,7 @@
           </a:xfrm>
           <a:prstGeom prst="roundRect">
             <a:avLst>
-              <a:gd name="adj" fmla="val 4000"/>
+              <a:gd name="adj" fmla="val 8000"/>
             </a:avLst>
           </a:prstGeom>
           <a:noFill/>
@@ -18268,7 +18398,7 @@
           </a:xfrm>
           <a:prstGeom prst="roundRect">
             <a:avLst>
-              <a:gd name="adj" fmla="val 4000"/>
+              <a:gd name="adj" fmla="val 8000"/>
             </a:avLst>
           </a:prstGeom>
           <a:noFill/>
@@ -18372,7 +18502,7 @@
           </a:xfrm>
           <a:prstGeom prst="roundRect">
             <a:avLst>
-              <a:gd name="adj" fmla="val 4000"/>
+              <a:gd name="adj" fmla="val 8000"/>
             </a:avLst>
           </a:prstGeom>
           <a:noFill/>
@@ -18476,7 +18606,7 @@
           </a:xfrm>
           <a:prstGeom prst="roundRect">
             <a:avLst>
-              <a:gd name="adj" fmla="val 4000"/>
+              <a:gd name="adj" fmla="val 8000"/>
             </a:avLst>
           </a:prstGeom>
           <a:noFill/>
@@ -18580,7 +18710,7 @@
           </a:xfrm>
           <a:prstGeom prst="roundRect">
             <a:avLst>
-              <a:gd name="adj" fmla="val 4000"/>
+              <a:gd name="adj" fmla="val 8000"/>
             </a:avLst>
           </a:prstGeom>
           <a:noFill/>
@@ -18684,7 +18814,7 @@
           </a:xfrm>
           <a:prstGeom prst="roundRect">
             <a:avLst>
-              <a:gd name="adj" fmla="val 4000"/>
+              <a:gd name="adj" fmla="val 8000"/>
             </a:avLst>
           </a:prstGeom>
           <a:noFill/>
@@ -18817,7 +18947,7 @@
             </a:pathLst>
           </a:custGeom>
           <a:solidFill>
-            <a:srgbClr val="150047"/>
+            <a:srgbClr val="2A3EF4"/>
           </a:solidFill>
           <a:ln>
             <a:noFill/>
@@ -19019,7 +19149,7 @@
             </a:pathLst>
           </a:custGeom>
           <a:solidFill>
-            <a:srgbClr val="150047"/>
+            <a:srgbClr val="2A3EF4"/>
           </a:solidFill>
           <a:ln>
             <a:noFill/>
@@ -19129,7 +19259,7 @@
           </a:xfrm>
           <a:prstGeom prst="roundRect">
             <a:avLst>
-              <a:gd name="adj" fmla="val 4000"/>
+              <a:gd name="adj" fmla="val 8000"/>
             </a:avLst>
           </a:prstGeom>
           <a:noFill/>
@@ -19225,9 +19355,9 @@
                 <a:solidFill>
                   <a:srgbClr val="150047"/>
                 </a:solidFill>
-                <a:latin typeface="Syne ExtraBold"/>
-                <a:ea typeface="Syne ExtraBold"/>
-                <a:cs typeface="Syne ExtraBold"/>
+                <a:latin typeface="Syne Bold"/>
+                <a:ea typeface="Syne Bold"/>
+                <a:cs typeface="Syne Bold"/>
                 <a:sym typeface="Arial Black"/>
               </a:rPr>
               <a:t>Tres niveles de madurez</a:t>
@@ -19257,7 +19387,7 @@
           </a:xfrm>
           <a:prstGeom prst="roundRect">
             <a:avLst>
-              <a:gd name="adj" fmla="val 4000"/>
+              <a:gd name="adj" fmla="val 8000"/>
             </a:avLst>
           </a:prstGeom>
           <a:solidFill>
@@ -19351,7 +19481,7 @@
             </a:pathLst>
           </a:custGeom>
           <a:solidFill>
-            <a:srgbClr val="95EBDA"/>
+            <a:srgbClr val="2A3EF4"/>
           </a:solidFill>
           <a:ln>
             <a:noFill/>
@@ -19398,7 +19528,7 @@
           </a:xfrm>
           <a:prstGeom prst="roundRect">
             <a:avLst>
-              <a:gd name="adj" fmla="val 4000"/>
+              <a:gd name="adj" fmla="val 8000"/>
             </a:avLst>
           </a:prstGeom>
           <a:noFill/>
@@ -19431,9 +19561,9 @@
                 <a:solidFill>
                   <a:srgbClr val="95EBDA"/>
                 </a:solidFill>
-                <a:latin typeface="Syne ExtraBold"/>
-                <a:ea typeface="Syne ExtraBold"/>
-                <a:cs typeface="Syne ExtraBold"/>
+                <a:latin typeface="Syne Bold"/>
+                <a:ea typeface="Syne Bold"/>
+                <a:cs typeface="Syne Bold"/>
                 <a:sym typeface="Arial Black"/>
               </a:rPr>
               <a:t>Nivel 1</a:t>
@@ -19463,7 +19593,7 @@
           </a:xfrm>
           <a:prstGeom prst="roundRect">
             <a:avLst>
-              <a:gd name="adj" fmla="val 4000"/>
+              <a:gd name="adj" fmla="val 8000"/>
             </a:avLst>
           </a:prstGeom>
           <a:noFill/>
@@ -19528,7 +19658,7 @@
           </a:xfrm>
           <a:prstGeom prst="roundRect">
             <a:avLst>
-              <a:gd name="adj" fmla="val 4000"/>
+              <a:gd name="adj" fmla="val 8000"/>
             </a:avLst>
           </a:prstGeom>
           <a:noFill/>
@@ -19593,7 +19723,7 @@
           </a:xfrm>
           <a:prstGeom prst="roundRect">
             <a:avLst>
-              <a:gd name="adj" fmla="val 4000"/>
+              <a:gd name="adj" fmla="val 8000"/>
             </a:avLst>
           </a:prstGeom>
           <a:solidFill>
@@ -19734,7 +19864,7 @@
           </a:xfrm>
           <a:prstGeom prst="roundRect">
             <a:avLst>
-              <a:gd name="adj" fmla="val 4000"/>
+              <a:gd name="adj" fmla="val 8000"/>
             </a:avLst>
           </a:prstGeom>
           <a:noFill/>
@@ -19767,9 +19897,9 @@
                 <a:solidFill>
                   <a:srgbClr val="FFFFFF"/>
                 </a:solidFill>
-                <a:latin typeface="Syne ExtraBold"/>
-                <a:ea typeface="Syne ExtraBold"/>
-                <a:cs typeface="Syne ExtraBold"/>
+                <a:latin typeface="Syne Bold"/>
+                <a:ea typeface="Syne Bold"/>
+                <a:cs typeface="Syne Bold"/>
                 <a:sym typeface="Arial Black"/>
               </a:rPr>
               <a:t>Nivel 2</a:t>
@@ -19799,7 +19929,7 @@
           </a:xfrm>
           <a:prstGeom prst="roundRect">
             <a:avLst>
-              <a:gd name="adj" fmla="val 4000"/>
+              <a:gd name="adj" fmla="val 8000"/>
             </a:avLst>
           </a:prstGeom>
           <a:noFill/>
@@ -19864,7 +19994,7 @@
           </a:xfrm>
           <a:prstGeom prst="roundRect">
             <a:avLst>
-              <a:gd name="adj" fmla="val 4000"/>
+              <a:gd name="adj" fmla="val 8000"/>
             </a:avLst>
           </a:prstGeom>
           <a:noFill/>
@@ -19929,7 +20059,7 @@
           </a:xfrm>
           <a:prstGeom prst="roundRect">
             <a:avLst>
-              <a:gd name="adj" fmla="val 4000"/>
+              <a:gd name="adj" fmla="val 8000"/>
             </a:avLst>
           </a:prstGeom>
           <a:solidFill>
@@ -20070,7 +20200,7 @@
           </a:xfrm>
           <a:prstGeom prst="roundRect">
             <a:avLst>
-              <a:gd name="adj" fmla="val 4000"/>
+              <a:gd name="adj" fmla="val 8000"/>
             </a:avLst>
           </a:prstGeom>
           <a:noFill/>
@@ -20103,9 +20233,9 @@
                 <a:solidFill>
                   <a:srgbClr val="150047"/>
                 </a:solidFill>
-                <a:latin typeface="Syne ExtraBold"/>
-                <a:ea typeface="Syne ExtraBold"/>
-                <a:cs typeface="Syne ExtraBold"/>
+                <a:latin typeface="Syne Bold"/>
+                <a:ea typeface="Syne Bold"/>
+                <a:cs typeface="Syne Bold"/>
                 <a:sym typeface="Arial Black"/>
               </a:rPr>
               <a:t>Nivel 3</a:t>
@@ -20135,7 +20265,7 @@
           </a:xfrm>
           <a:prstGeom prst="roundRect">
             <a:avLst>
-              <a:gd name="adj" fmla="val 4000"/>
+              <a:gd name="adj" fmla="val 8000"/>
             </a:avLst>
           </a:prstGeom>
           <a:noFill/>
@@ -20200,7 +20330,7 @@
           </a:xfrm>
           <a:prstGeom prst="roundRect">
             <a:avLst>
-              <a:gd name="adj" fmla="val 4000"/>
+              <a:gd name="adj" fmla="val 8000"/>
             </a:avLst>
           </a:prstGeom>
           <a:noFill/>
@@ -20301,7 +20431,7 @@
             </a:pathLst>
           </a:custGeom>
           <a:solidFill>
-            <a:srgbClr val="150047"/>
+            <a:srgbClr val="2A3EF4"/>
           </a:solidFill>
           <a:ln>
             <a:noFill/>
@@ -20550,7 +20680,7 @@
           </a:xfrm>
           <a:prstGeom prst="roundRect">
             <a:avLst>
-              <a:gd name="adj" fmla="val 4000"/>
+              <a:gd name="adj" fmla="val 8000"/>
             </a:avLst>
           </a:prstGeom>
           <a:noFill/>
@@ -20583,9 +20713,9 @@
                 <a:solidFill>
                   <a:srgbClr val="95EBDA"/>
                 </a:solidFill>
-                <a:latin typeface="Syne ExtraBold"/>
-                <a:ea typeface="Syne ExtraBold"/>
-                <a:cs typeface="Syne ExtraBold"/>
+                <a:latin typeface="Syne Bold"/>
+                <a:ea typeface="Syne Bold"/>
+                <a:cs typeface="Syne Bold"/>
                 <a:sym typeface="Arial Black"/>
               </a:rPr>
               <a:t>08</a:t>
@@ -20615,7 +20745,7 @@
           </a:xfrm>
           <a:prstGeom prst="roundRect">
             <a:avLst>
-              <a:gd name="adj" fmla="val 4000"/>
+              <a:gd name="adj" fmla="val 8000"/>
             </a:avLst>
           </a:prstGeom>
           <a:noFill/>
@@ -20787,7 +20917,7 @@
           </a:xfrm>
           <a:prstGeom prst="roundRect">
             <a:avLst>
-              <a:gd name="adj" fmla="val 4000"/>
+              <a:gd name="adj" fmla="val 8000"/>
             </a:avLst>
           </a:prstGeom>
           <a:noFill/>
@@ -20798,14 +20928,40 @@
       </p:pic>
       <p:pic>
         <p:nvPicPr>
-          <p:cNvPr id="397" name="Picture 396" descr="LOGO ISI CLARO.png"/>
+          <p:cNvPr id="397" name="Picture 396" descr="logo_isi_WHITE.png"/>
           <p:cNvPicPr>
             <a:picLocks noChangeAspect="1"/>
           </p:cNvPicPr>
           <p:nvPr/>
         </p:nvPicPr>
         <p:blipFill>
-          <a:blip r:embed="rId4"/>
+          <a:blip r:embed="rId4">
+            <a:alphaModFix amt="15000"/>
+          </a:blip>
+          <a:stretch>
+            <a:fillRect/>
+          </a:stretch>
+        </p:blipFill>
+        <p:spPr>
+          <a:xfrm>
+            <a:off x="6126480" y="2125980"/>
+            <a:ext cx="2743200" cy="2743200"/>
+          </a:xfrm>
+          <a:prstGeom prst="rect">
+            <a:avLst/>
+          </a:prstGeom>
+        </p:spPr>
+      </p:pic>
+      <p:pic>
+        <p:nvPicPr>
+          <p:cNvPr id="398" name="Picture 397" descr="LOGO ISI CLARO.png"/>
+          <p:cNvPicPr>
+            <a:picLocks noChangeAspect="1"/>
+          </p:cNvPicPr>
+          <p:nvPr/>
+        </p:nvPicPr>
+        <p:blipFill>
+          <a:blip r:embed="rId5"/>
           <a:stretch>
             <a:fillRect/>
           </a:stretch>
@@ -20901,7 +21057,7 @@
             </a:pathLst>
           </a:custGeom>
           <a:solidFill>
-            <a:srgbClr val="150047"/>
+            <a:srgbClr val="2A3EF4"/>
           </a:solidFill>
           <a:ln>
             <a:noFill/>
@@ -21011,7 +21167,7 @@
           </a:xfrm>
           <a:prstGeom prst="roundRect">
             <a:avLst>
-              <a:gd name="adj" fmla="val 4000"/>
+              <a:gd name="adj" fmla="val 8000"/>
             </a:avLst>
           </a:prstGeom>
           <a:noFill/>
@@ -21107,9 +21263,9 @@
                 <a:solidFill>
                   <a:srgbClr val="150047"/>
                 </a:solidFill>
-                <a:latin typeface="Syne ExtraBold"/>
-                <a:ea typeface="Syne ExtraBold"/>
-                <a:cs typeface="Syne ExtraBold"/>
+                <a:latin typeface="Syne Bold"/>
+                <a:ea typeface="Syne Bold"/>
+                <a:cs typeface="Syne Bold"/>
                 <a:sym typeface="Arial Black"/>
               </a:rPr>
               <a:t>4 características de un buen objetivo</a:t>
@@ -21139,7 +21295,7 @@
           </a:xfrm>
           <a:prstGeom prst="roundRect">
             <a:avLst>
-              <a:gd name="adj" fmla="val 4000"/>
+              <a:gd name="adj" fmla="val 8000"/>
             </a:avLst>
           </a:prstGeom>
           <a:solidFill>
@@ -21197,11 +21353,11 @@
           </a:xfrm>
           <a:prstGeom prst="roundRect">
             <a:avLst>
-              <a:gd name="adj" fmla="val 4000"/>
+              <a:gd name="adj" fmla="val 8000"/>
             </a:avLst>
           </a:prstGeom>
           <a:solidFill>
-            <a:srgbClr val="95EBDA"/>
+            <a:srgbClr val="2A3EF4"/>
           </a:solidFill>
           <a:ln>
             <a:noFill/>
@@ -21248,7 +21404,7 @@
           </a:xfrm>
           <a:prstGeom prst="roundRect">
             <a:avLst>
-              <a:gd name="adj" fmla="val 4000"/>
+              <a:gd name="adj" fmla="val 8000"/>
             </a:avLst>
           </a:prstGeom>
           <a:noFill/>
@@ -21281,9 +21437,9 @@
                 <a:solidFill>
                   <a:srgbClr val="FFFFFF"/>
                 </a:solidFill>
-                <a:latin typeface="Syne ExtraBold"/>
-                <a:ea typeface="Syne ExtraBold"/>
-                <a:cs typeface="Syne ExtraBold"/>
+                <a:latin typeface="Syne Bold"/>
+                <a:ea typeface="Syne Bold"/>
+                <a:cs typeface="Syne Bold"/>
                 <a:sym typeface="Arial Black"/>
               </a:rPr>
               <a:t>1</a:t>
@@ -21313,7 +21469,7 @@
           </a:xfrm>
           <a:prstGeom prst="roundRect">
             <a:avLst>
-              <a:gd name="adj" fmla="val 4000"/>
+              <a:gd name="adj" fmla="val 8000"/>
             </a:avLst>
           </a:prstGeom>
           <a:noFill/>
@@ -21378,7 +21534,7 @@
           </a:xfrm>
           <a:prstGeom prst="roundRect">
             <a:avLst>
-              <a:gd name="adj" fmla="val 4000"/>
+              <a:gd name="adj" fmla="val 8000"/>
             </a:avLst>
           </a:prstGeom>
           <a:noFill/>
@@ -21480,7 +21636,7 @@
           </a:xfrm>
           <a:prstGeom prst="roundRect">
             <a:avLst>
-              <a:gd name="adj" fmla="val 4000"/>
+              <a:gd name="adj" fmla="val 8000"/>
             </a:avLst>
           </a:prstGeom>
           <a:solidFill>
@@ -21538,7 +21694,7 @@
           </a:xfrm>
           <a:prstGeom prst="roundRect">
             <a:avLst>
-              <a:gd name="adj" fmla="val 4000"/>
+              <a:gd name="adj" fmla="val 8000"/>
             </a:avLst>
           </a:prstGeom>
           <a:solidFill>
@@ -21589,7 +21745,7 @@
           </a:xfrm>
           <a:prstGeom prst="roundRect">
             <a:avLst>
-              <a:gd name="adj" fmla="val 4000"/>
+              <a:gd name="adj" fmla="val 8000"/>
             </a:avLst>
           </a:prstGeom>
           <a:noFill/>
@@ -21622,9 +21778,9 @@
                 <a:solidFill>
                   <a:srgbClr val="FFFFFF"/>
                 </a:solidFill>
-                <a:latin typeface="Syne ExtraBold"/>
-                <a:ea typeface="Syne ExtraBold"/>
-                <a:cs typeface="Syne ExtraBold"/>
+                <a:latin typeface="Syne Bold"/>
+                <a:ea typeface="Syne Bold"/>
+                <a:cs typeface="Syne Bold"/>
                 <a:sym typeface="Arial Black"/>
               </a:rPr>
               <a:t>2</a:t>
@@ -21654,7 +21810,7 @@
           </a:xfrm>
           <a:prstGeom prst="roundRect">
             <a:avLst>
-              <a:gd name="adj" fmla="val 4000"/>
+              <a:gd name="adj" fmla="val 8000"/>
             </a:avLst>
           </a:prstGeom>
           <a:noFill/>
@@ -21719,7 +21875,7 @@
           </a:xfrm>
           <a:prstGeom prst="roundRect">
             <a:avLst>
-              <a:gd name="adj" fmla="val 4000"/>
+              <a:gd name="adj" fmla="val 8000"/>
             </a:avLst>
           </a:prstGeom>
           <a:noFill/>
@@ -21821,7 +21977,7 @@
           </a:xfrm>
           <a:prstGeom prst="roundRect">
             <a:avLst>
-              <a:gd name="adj" fmla="val 4000"/>
+              <a:gd name="adj" fmla="val 8000"/>
             </a:avLst>
           </a:prstGeom>
           <a:solidFill>
@@ -21879,7 +22035,7 @@
           </a:xfrm>
           <a:prstGeom prst="roundRect">
             <a:avLst>
-              <a:gd name="adj" fmla="val 4000"/>
+              <a:gd name="adj" fmla="val 8000"/>
             </a:avLst>
           </a:prstGeom>
           <a:solidFill>
@@ -21930,7 +22086,7 @@
           </a:xfrm>
           <a:prstGeom prst="roundRect">
             <a:avLst>
-              <a:gd name="adj" fmla="val 4000"/>
+              <a:gd name="adj" fmla="val 8000"/>
             </a:avLst>
           </a:prstGeom>
           <a:noFill/>
@@ -21963,9 +22119,9 @@
                 <a:solidFill>
                   <a:srgbClr val="FFFFFF"/>
                 </a:solidFill>
-                <a:latin typeface="Syne ExtraBold"/>
-                <a:ea typeface="Syne ExtraBold"/>
-                <a:cs typeface="Syne ExtraBold"/>
+                <a:latin typeface="Syne Bold"/>
+                <a:ea typeface="Syne Bold"/>
+                <a:cs typeface="Syne Bold"/>
                 <a:sym typeface="Arial Black"/>
               </a:rPr>
               <a:t>3</a:t>
@@ -21995,7 +22151,7 @@
           </a:xfrm>
           <a:prstGeom prst="roundRect">
             <a:avLst>
-              <a:gd name="adj" fmla="val 4000"/>
+              <a:gd name="adj" fmla="val 8000"/>
             </a:avLst>
           </a:prstGeom>
           <a:noFill/>
@@ -22060,7 +22216,7 @@
           </a:xfrm>
           <a:prstGeom prst="roundRect">
             <a:avLst>
-              <a:gd name="adj" fmla="val 4000"/>
+              <a:gd name="adj" fmla="val 8000"/>
             </a:avLst>
           </a:prstGeom>
           <a:noFill/>
@@ -22162,7 +22318,7 @@
           </a:xfrm>
           <a:prstGeom prst="roundRect">
             <a:avLst>
-              <a:gd name="adj" fmla="val 4000"/>
+              <a:gd name="adj" fmla="val 8000"/>
             </a:avLst>
           </a:prstGeom>
           <a:solidFill>
@@ -22220,7 +22376,7 @@
           </a:xfrm>
           <a:prstGeom prst="roundRect">
             <a:avLst>
-              <a:gd name="adj" fmla="val 4000"/>
+              <a:gd name="adj" fmla="val 8000"/>
             </a:avLst>
           </a:prstGeom>
           <a:solidFill>
@@ -22271,7 +22427,7 @@
           </a:xfrm>
           <a:prstGeom prst="roundRect">
             <a:avLst>
-              <a:gd name="adj" fmla="val 4000"/>
+              <a:gd name="adj" fmla="val 8000"/>
             </a:avLst>
           </a:prstGeom>
           <a:noFill/>
@@ -22304,9 +22460,9 @@
                 <a:solidFill>
                   <a:srgbClr val="FFFFFF"/>
                 </a:solidFill>
-                <a:latin typeface="Syne ExtraBold"/>
-                <a:ea typeface="Syne ExtraBold"/>
-                <a:cs typeface="Syne ExtraBold"/>
+                <a:latin typeface="Syne Bold"/>
+                <a:ea typeface="Syne Bold"/>
+                <a:cs typeface="Syne Bold"/>
                 <a:sym typeface="Arial Black"/>
               </a:rPr>
               <a:t>4</a:t>
@@ -22336,7 +22492,7 @@
           </a:xfrm>
           <a:prstGeom prst="roundRect">
             <a:avLst>
-              <a:gd name="adj" fmla="val 4000"/>
+              <a:gd name="adj" fmla="val 8000"/>
             </a:avLst>
           </a:prstGeom>
           <a:noFill/>
@@ -22401,7 +22557,7 @@
           </a:xfrm>
           <a:prstGeom prst="roundRect">
             <a:avLst>
-              <a:gd name="adj" fmla="val 4000"/>
+              <a:gd name="adj" fmla="val 8000"/>
             </a:avLst>
           </a:prstGeom>
           <a:noFill/>
@@ -22539,7 +22695,7 @@
             </a:pathLst>
           </a:custGeom>
           <a:solidFill>
-            <a:srgbClr val="150047"/>
+            <a:srgbClr val="2A3EF4"/>
           </a:solidFill>
           <a:ln>
             <a:noFill/>
@@ -22795,7 +22951,7 @@
           </a:xfrm>
           <a:prstGeom prst="roundRect">
             <a:avLst>
-              <a:gd name="adj" fmla="val 4000"/>
+              <a:gd name="adj" fmla="val 8000"/>
             </a:avLst>
           </a:prstGeom>
           <a:noFill/>
@@ -22828,9 +22984,9 @@
                 <a:solidFill>
                   <a:srgbClr val="95EBDA"/>
                 </a:solidFill>
-                <a:latin typeface="Syne ExtraBold"/>
-                <a:ea typeface="Syne ExtraBold"/>
-                <a:cs typeface="Syne ExtraBold"/>
+                <a:latin typeface="Syne Bold"/>
+                <a:ea typeface="Syne Bold"/>
+                <a:cs typeface="Syne Bold"/>
                 <a:sym typeface="Arial Black"/>
               </a:rPr>
               <a:t>09</a:t>
@@ -22860,7 +23016,7 @@
           </a:xfrm>
           <a:prstGeom prst="roundRect">
             <a:avLst>
-              <a:gd name="adj" fmla="val 4000"/>
+              <a:gd name="adj" fmla="val 8000"/>
             </a:avLst>
           </a:prstGeom>
           <a:noFill/>
@@ -23032,7 +23188,7 @@
           </a:xfrm>
           <a:prstGeom prst="roundRect">
             <a:avLst>
-              <a:gd name="adj" fmla="val 4000"/>
+              <a:gd name="adj" fmla="val 8000"/>
             </a:avLst>
           </a:prstGeom>
           <a:noFill/>
@@ -23043,14 +23199,40 @@
       </p:pic>
       <p:pic>
         <p:nvPicPr>
-          <p:cNvPr id="438" name="Picture 437" descr="LOGO ISI CLARO.png"/>
+          <p:cNvPr id="438" name="Picture 437" descr="logo_isi_WHITE.png"/>
           <p:cNvPicPr>
             <a:picLocks noChangeAspect="1"/>
           </p:cNvPicPr>
           <p:nvPr/>
         </p:nvPicPr>
         <p:blipFill>
-          <a:blip r:embed="rId4"/>
+          <a:blip r:embed="rId4">
+            <a:alphaModFix amt="15000"/>
+          </a:blip>
+          <a:stretch>
+            <a:fillRect/>
+          </a:stretch>
+        </p:blipFill>
+        <p:spPr>
+          <a:xfrm>
+            <a:off x="6126480" y="2125980"/>
+            <a:ext cx="2743200" cy="2743200"/>
+          </a:xfrm>
+          <a:prstGeom prst="rect">
+            <a:avLst/>
+          </a:prstGeom>
+        </p:spPr>
+      </p:pic>
+      <p:pic>
+        <p:nvPicPr>
+          <p:cNvPr id="439" name="Picture 438" descr="LOGO ISI CLARO.png"/>
+          <p:cNvPicPr>
+            <a:picLocks noChangeAspect="1"/>
+          </p:cNvPicPr>
+          <p:nvPr/>
+        </p:nvPicPr>
+        <p:blipFill>
+          <a:blip r:embed="rId5"/>
           <a:stretch>
             <a:fillRect/>
           </a:stretch>
@@ -23146,7 +23328,7 @@
             </a:pathLst>
           </a:custGeom>
           <a:solidFill>
-            <a:srgbClr val="150047"/>
+            <a:srgbClr val="2A3EF4"/>
           </a:solidFill>
           <a:ln>
             <a:noFill/>
@@ -23256,7 +23438,7 @@
           </a:xfrm>
           <a:prstGeom prst="roundRect">
             <a:avLst>
-              <a:gd name="adj" fmla="val 4000"/>
+              <a:gd name="adj" fmla="val 8000"/>
             </a:avLst>
           </a:prstGeom>
           <a:noFill/>
@@ -23352,9 +23534,9 @@
                 <a:solidFill>
                   <a:srgbClr val="150047"/>
                 </a:solidFill>
-                <a:latin typeface="Syne ExtraBold"/>
-                <a:ea typeface="Syne ExtraBold"/>
-                <a:cs typeface="Syne ExtraBold"/>
+                <a:latin typeface="Syne Bold"/>
+                <a:ea typeface="Syne Bold"/>
+                <a:cs typeface="Syne Bold"/>
                 <a:sym typeface="Arial Black"/>
               </a:rPr>
               <a:t>Tu checklist mínimo</a:t>
@@ -23384,7 +23566,7 @@
           </a:xfrm>
           <a:prstGeom prst="roundRect">
             <a:avLst>
-              <a:gd name="adj" fmla="val 4000"/>
+              <a:gd name="adj" fmla="val 8000"/>
             </a:avLst>
           </a:prstGeom>
           <a:solidFill>
@@ -23478,7 +23660,7 @@
             </a:pathLst>
           </a:custGeom>
           <a:solidFill>
-            <a:srgbClr val="95EBDA"/>
+            <a:srgbClr val="2A3EF4"/>
           </a:solidFill>
           <a:ln>
             <a:noFill/>
@@ -23532,7 +23714,7 @@
           </a:xfrm>
           <a:prstGeom prst="roundRect">
             <a:avLst>
-              <a:gd name="adj" fmla="val 4000"/>
+              <a:gd name="adj" fmla="val 8000"/>
             </a:avLst>
           </a:prstGeom>
           <a:noFill/>
@@ -23554,7 +23736,7 @@
           </a:xfrm>
           <a:prstGeom prst="roundRect">
             <a:avLst>
-              <a:gd name="adj" fmla="val 4000"/>
+              <a:gd name="adj" fmla="val 8000"/>
             </a:avLst>
           </a:prstGeom>
           <a:noFill/>
@@ -23619,7 +23801,7 @@
           </a:xfrm>
           <a:prstGeom prst="roundRect">
             <a:avLst>
-              <a:gd name="adj" fmla="val 4000"/>
+              <a:gd name="adj" fmla="val 8000"/>
             </a:avLst>
           </a:prstGeom>
           <a:noFill/>
@@ -23679,12 +23861,12 @@
         </p:nvSpPr>
         <p:spPr>
           <a:xfrm>
-            <a:off x="640080" y="2057400"/>
+            <a:off x="640080" y="1977400"/>
             <a:ext cx="3749040" cy="1051560"/>
           </a:xfrm>
           <a:prstGeom prst="roundRect">
             <a:avLst>
-              <a:gd name="adj" fmla="val 4000"/>
+              <a:gd name="adj" fmla="val 8000"/>
             </a:avLst>
           </a:prstGeom>
           <a:solidFill>
@@ -23737,7 +23919,7 @@
         </p:nvSpPr>
         <p:spPr>
           <a:xfrm>
-            <a:off x="640080" y="2057400"/>
+            <a:off x="640080" y="1977400"/>
             <a:ext cx="64008" cy="1051560"/>
           </a:xfrm>
           <a:custGeom>
@@ -23778,7 +23960,7 @@
             </a:pathLst>
           </a:custGeom>
           <a:solidFill>
-            <a:srgbClr val="95EBDA"/>
+            <a:srgbClr val="2A3EF4"/>
           </a:solidFill>
           <a:ln>
             <a:noFill/>
@@ -23827,12 +24009,12 @@
         </p:blipFill>
         <p:spPr>
           <a:xfrm>
-            <a:off x="868680" y="2167128"/>
+            <a:off x="868680" y="2087128"/>
             <a:ext cx="292608" cy="292608"/>
           </a:xfrm>
           <a:prstGeom prst="roundRect">
             <a:avLst>
-              <a:gd name="adj" fmla="val 4000"/>
+              <a:gd name="adj" fmla="val 8000"/>
             </a:avLst>
           </a:prstGeom>
           <a:noFill/>
@@ -23849,12 +24031,12 @@
         </p:nvSpPr>
         <p:spPr>
           <a:xfrm>
-            <a:off x="1280160" y="2130552"/>
+            <a:off x="1280160" y="2050552"/>
             <a:ext cx="2926080" cy="365760"/>
           </a:xfrm>
           <a:prstGeom prst="roundRect">
             <a:avLst>
-              <a:gd name="adj" fmla="val 4000"/>
+              <a:gd name="adj" fmla="val 8000"/>
             </a:avLst>
           </a:prstGeom>
           <a:noFill/>
@@ -23914,12 +24096,12 @@
         </p:nvSpPr>
         <p:spPr>
           <a:xfrm>
-            <a:off x="1280160" y="2514600"/>
+            <a:off x="1280160" y="2434600"/>
             <a:ext cx="2926080" cy="502920"/>
           </a:xfrm>
           <a:prstGeom prst="roundRect">
             <a:avLst>
-              <a:gd name="adj" fmla="val 4000"/>
+              <a:gd name="adj" fmla="val 8000"/>
             </a:avLst>
           </a:prstGeom>
           <a:noFill/>
@@ -23979,12 +24161,12 @@
         </p:nvSpPr>
         <p:spPr>
           <a:xfrm>
-            <a:off x="640080" y="3291840"/>
-            <a:ext cx="3749040" cy="1051560"/>
+            <a:off x="640080" y="3091840"/>
+            <a:ext cx="3749040" cy="801560"/>
           </a:xfrm>
           <a:prstGeom prst="roundRect">
             <a:avLst>
-              <a:gd name="adj" fmla="val 4000"/>
+              <a:gd name="adj" fmla="val 8000"/>
             </a:avLst>
           </a:prstGeom>
           <a:solidFill>
@@ -24037,8 +24219,8 @@
         </p:nvSpPr>
         <p:spPr>
           <a:xfrm>
-            <a:off x="640080" y="3291840"/>
-            <a:ext cx="64008" cy="1051560"/>
+            <a:off x="640080" y="3091840"/>
+            <a:ext cx="64008" cy="801560"/>
           </a:xfrm>
           <a:custGeom>
             <a:rect b="b" l="l" r="r" t="t"/>
@@ -24078,7 +24260,7 @@
             </a:pathLst>
           </a:custGeom>
           <a:solidFill>
-            <a:srgbClr val="95EBDA"/>
+            <a:srgbClr val="2A3EF4"/>
           </a:solidFill>
           <a:ln>
             <a:noFill/>
@@ -24127,12 +24309,12 @@
         </p:blipFill>
         <p:spPr>
           <a:xfrm>
-            <a:off x="868680" y="3401568"/>
+            <a:off x="868680" y="3201568"/>
             <a:ext cx="292608" cy="292608"/>
           </a:xfrm>
           <a:prstGeom prst="roundRect">
             <a:avLst>
-              <a:gd name="adj" fmla="val 4000"/>
+              <a:gd name="adj" fmla="val 8000"/>
             </a:avLst>
           </a:prstGeom>
           <a:noFill/>
@@ -24149,12 +24331,12 @@
         </p:nvSpPr>
         <p:spPr>
           <a:xfrm>
-            <a:off x="1280160" y="3364992"/>
+            <a:off x="1280160" y="3164992"/>
             <a:ext cx="2926080" cy="365760"/>
           </a:xfrm>
           <a:prstGeom prst="roundRect">
             <a:avLst>
-              <a:gd name="adj" fmla="val 4000"/>
+              <a:gd name="adj" fmla="val 8000"/>
             </a:avLst>
           </a:prstGeom>
           <a:noFill/>
@@ -24214,12 +24396,12 @@
         </p:nvSpPr>
         <p:spPr>
           <a:xfrm>
-            <a:off x="1280160" y="3749040"/>
+            <a:off x="1280160" y="3549040"/>
             <a:ext cx="2926080" cy="502920"/>
           </a:xfrm>
           <a:prstGeom prst="roundRect">
             <a:avLst>
-              <a:gd name="adj" fmla="val 4000"/>
+              <a:gd name="adj" fmla="val 8000"/>
             </a:avLst>
           </a:prstGeom>
           <a:noFill/>
@@ -24284,7 +24466,7 @@
           </a:xfrm>
           <a:prstGeom prst="roundRect">
             <a:avLst>
-              <a:gd name="adj" fmla="val 4000"/>
+              <a:gd name="adj" fmla="val 8000"/>
             </a:avLst>
           </a:prstGeom>
           <a:solidFill>
@@ -24378,7 +24560,7 @@
             </a:pathLst>
           </a:custGeom>
           <a:solidFill>
-            <a:srgbClr val="95EBDA"/>
+            <a:srgbClr val="2A3EF4"/>
           </a:solidFill>
           <a:ln>
             <a:noFill/>
@@ -24432,7 +24614,7 @@
           </a:xfrm>
           <a:prstGeom prst="roundRect">
             <a:avLst>
-              <a:gd name="adj" fmla="val 4000"/>
+              <a:gd name="adj" fmla="val 8000"/>
             </a:avLst>
           </a:prstGeom>
           <a:noFill/>
@@ -24454,7 +24636,7 @@
           </a:xfrm>
           <a:prstGeom prst="roundRect">
             <a:avLst>
-              <a:gd name="adj" fmla="val 4000"/>
+              <a:gd name="adj" fmla="val 8000"/>
             </a:avLst>
           </a:prstGeom>
           <a:noFill/>
@@ -24519,7 +24701,7 @@
           </a:xfrm>
           <a:prstGeom prst="roundRect">
             <a:avLst>
-              <a:gd name="adj" fmla="val 4000"/>
+              <a:gd name="adj" fmla="val 8000"/>
             </a:avLst>
           </a:prstGeom>
           <a:noFill/>
@@ -24579,12 +24761,12 @@
         </p:nvSpPr>
         <p:spPr>
           <a:xfrm>
-            <a:off x="4754880" y="2057400"/>
+            <a:off x="4754880" y="1977400"/>
             <a:ext cx="3749040" cy="1051560"/>
           </a:xfrm>
           <a:prstGeom prst="roundRect">
             <a:avLst>
-              <a:gd name="adj" fmla="val 4000"/>
+              <a:gd name="adj" fmla="val 8000"/>
             </a:avLst>
           </a:prstGeom>
           <a:solidFill>
@@ -24637,7 +24819,7 @@
         </p:nvSpPr>
         <p:spPr>
           <a:xfrm>
-            <a:off x="4754880" y="2057400"/>
+            <a:off x="4754880" y="1977400"/>
             <a:ext cx="64008" cy="1051560"/>
           </a:xfrm>
           <a:custGeom>
@@ -24678,7 +24860,7 @@
             </a:pathLst>
           </a:custGeom>
           <a:solidFill>
-            <a:srgbClr val="95EBDA"/>
+            <a:srgbClr val="2A3EF4"/>
           </a:solidFill>
           <a:ln>
             <a:noFill/>
@@ -24727,12 +24909,12 @@
         </p:blipFill>
         <p:spPr>
           <a:xfrm>
-            <a:off x="4983480" y="2167128"/>
+            <a:off x="4983480" y="2087128"/>
             <a:ext cx="292608" cy="292608"/>
           </a:xfrm>
           <a:prstGeom prst="roundRect">
             <a:avLst>
-              <a:gd name="adj" fmla="val 4000"/>
+              <a:gd name="adj" fmla="val 8000"/>
             </a:avLst>
           </a:prstGeom>
           <a:noFill/>
@@ -24749,12 +24931,12 @@
         </p:nvSpPr>
         <p:spPr>
           <a:xfrm>
-            <a:off x="5394960" y="2130552"/>
+            <a:off x="5394960" y="2050552"/>
             <a:ext cx="2926080" cy="365760"/>
           </a:xfrm>
           <a:prstGeom prst="roundRect">
             <a:avLst>
-              <a:gd name="adj" fmla="val 4000"/>
+              <a:gd name="adj" fmla="val 8000"/>
             </a:avLst>
           </a:prstGeom>
           <a:noFill/>
@@ -24814,12 +24996,12 @@
         </p:nvSpPr>
         <p:spPr>
           <a:xfrm>
-            <a:off x="5394960" y="2514600"/>
+            <a:off x="5394960" y="2434600"/>
             <a:ext cx="2926080" cy="502920"/>
           </a:xfrm>
           <a:prstGeom prst="roundRect">
             <a:avLst>
-              <a:gd name="adj" fmla="val 4000"/>
+              <a:gd name="adj" fmla="val 8000"/>
             </a:avLst>
           </a:prstGeom>
           <a:noFill/>
@@ -24879,8 +25061,8 @@
         </p:nvSpPr>
         <p:spPr>
           <a:xfrm>
-            <a:off x="640080" y="3931920"/>
-            <a:ext cx="7863840" cy="548640"/>
+            <a:off x="640080" y="4160000"/>
+            <a:ext cx="7863840" cy="400000"/>
           </a:xfrm>
           <a:custGeom>
             <a:rect b="b" l="l" r="r" t="t"/>
@@ -24920,7 +25102,7 @@
             </a:pathLst>
           </a:custGeom>
           <a:solidFill>
-            <a:srgbClr val="150047"/>
+            <a:srgbClr val="2A3EF4"/>
           </a:solidFill>
           <a:ln>
             <a:noFill/>
@@ -24962,8 +25144,8 @@
         </p:nvSpPr>
         <p:spPr>
           <a:xfrm>
-            <a:off x="914400" y="3931920"/>
-            <a:ext cx="7315200" cy="548640"/>
+            <a:off x="914400" y="4160000"/>
+            <a:ext cx="7315200" cy="400000"/>
           </a:xfrm>
           <a:prstGeom prst="rect">
             <a:avLst/>
@@ -25033,7 +25215,7 @@
         </p:blipFill>
         <p:spPr>
           <a:xfrm>
-            <a:off x="457200" y="4343400"/>
+            <a:off x="7589520" y="4343400"/>
             <a:ext cx="1097280" cy="274320"/>
           </a:xfrm>
           <a:prstGeom prst="rect">
@@ -25339,7 +25521,7 @@
           </a:xfrm>
           <a:prstGeom prst="roundRect">
             <a:avLst>
-              <a:gd name="adj" fmla="val 4000"/>
+              <a:gd name="adj" fmla="val 8000"/>
             </a:avLst>
           </a:prstGeom>
           <a:noFill/>
@@ -25372,9 +25554,9 @@
                 <a:solidFill>
                   <a:srgbClr val="FFFFFF"/>
                 </a:solidFill>
-                <a:latin typeface="Syne ExtraBold"/>
-                <a:ea typeface="Syne ExtraBold"/>
-                <a:cs typeface="Syne ExtraBold"/>
+                <a:latin typeface="Syne Bold"/>
+                <a:ea typeface="Syne Bold"/>
+                <a:cs typeface="Syne Bold"/>
                 <a:sym typeface="Arial Black"/>
               </a:rPr>
               <a:t>Gracias</a:t>
@@ -25487,7 +25669,7 @@
           </a:xfrm>
           <a:prstGeom prst="roundRect">
             <a:avLst>
-              <a:gd name="adj" fmla="val 4000"/>
+              <a:gd name="adj" fmla="val 8000"/>
             </a:avLst>
           </a:prstGeom>
           <a:noFill/>
@@ -25696,7 +25878,7 @@
           </a:xfrm>
           <a:prstGeom prst="roundRect">
             <a:avLst>
-              <a:gd name="adj" fmla="val 4000"/>
+              <a:gd name="adj" fmla="val 8000"/>
             </a:avLst>
           </a:prstGeom>
           <a:noFill/>
@@ -25707,14 +25889,40 @@
       </p:pic>
       <p:pic>
         <p:nvPicPr>
-          <p:cNvPr id="487" name="Picture 486" descr="LOGO ISI CLARO.png"/>
+          <p:cNvPr id="487" name="Picture 486" descr="logo_isi_WHITE.png"/>
           <p:cNvPicPr>
             <a:picLocks noChangeAspect="1"/>
           </p:cNvPicPr>
           <p:nvPr/>
         </p:nvPicPr>
         <p:blipFill>
-          <a:blip r:embed="rId4"/>
+          <a:blip r:embed="rId4">
+            <a:alphaModFix amt="15000"/>
+          </a:blip>
+          <a:stretch>
+            <a:fillRect/>
+          </a:stretch>
+        </p:blipFill>
+        <p:spPr>
+          <a:xfrm>
+            <a:off x="6126480" y="2125980"/>
+            <a:ext cx="2743200" cy="2743200"/>
+          </a:xfrm>
+          <a:prstGeom prst="rect">
+            <a:avLst/>
+          </a:prstGeom>
+        </p:spPr>
+      </p:pic>
+      <p:pic>
+        <p:nvPicPr>
+          <p:cNvPr id="488" name="Picture 487" descr="LOGO ISI CLARO.png"/>
+          <p:cNvPicPr>
+            <a:picLocks noChangeAspect="1"/>
+          </p:cNvPicPr>
+          <p:nvPr/>
+        </p:nvPicPr>
+        <p:blipFill>
+          <a:blip r:embed="rId5"/>
           <a:stretch>
             <a:fillRect/>
           </a:stretch>
@@ -25857,7 +26065,7 @@
           </a:xfrm>
           <a:prstGeom prst="roundRect">
             <a:avLst>
-              <a:gd name="adj" fmla="val 4000"/>
+              <a:gd name="adj" fmla="val 8000"/>
             </a:avLst>
           </a:prstGeom>
           <a:noFill/>
@@ -25890,9 +26098,9 @@
                 <a:solidFill>
                   <a:srgbClr val="95EBDA"/>
                 </a:solidFill>
-                <a:latin typeface="Syne ExtraBold"/>
-                <a:ea typeface="Syne ExtraBold"/>
-                <a:cs typeface="Syne ExtraBold"/>
+                <a:latin typeface="Syne Bold"/>
+                <a:ea typeface="Syne Bold"/>
+                <a:cs typeface="Syne Bold"/>
                 <a:sym typeface="Arial Black"/>
               </a:rPr>
               <a:t>01</a:t>
@@ -25922,7 +26130,7 @@
           </a:xfrm>
           <a:prstGeom prst="roundRect">
             <a:avLst>
-              <a:gd name="adj" fmla="val 4000"/>
+              <a:gd name="adj" fmla="val 8000"/>
             </a:avLst>
           </a:prstGeom>
           <a:noFill/>
@@ -26024,7 +26232,7 @@
           </a:xfrm>
           <a:prstGeom prst="roundRect">
             <a:avLst>
-              <a:gd name="adj" fmla="val 4000"/>
+              <a:gd name="adj" fmla="val 8000"/>
             </a:avLst>
           </a:prstGeom>
           <a:noFill/>
@@ -26096,7 +26304,7 @@
           </a:xfrm>
           <a:prstGeom prst="roundRect">
             <a:avLst>
-              <a:gd name="adj" fmla="val 4000"/>
+              <a:gd name="adj" fmla="val 8000"/>
             </a:avLst>
           </a:prstGeom>
           <a:noFill/>
@@ -26107,14 +26315,40 @@
       </p:pic>
       <p:pic>
         <p:nvPicPr>
-          <p:cNvPr id="63" name="Picture 62" descr="LOGO ISI CLARO.png"/>
+          <p:cNvPr id="63" name="Picture 62" descr="logo_isi_WHITE.png"/>
           <p:cNvPicPr>
             <a:picLocks noChangeAspect="1"/>
           </p:cNvPicPr>
           <p:nvPr/>
         </p:nvPicPr>
         <p:blipFill>
-          <a:blip r:embed="rId4"/>
+          <a:blip r:embed="rId4">
+            <a:alphaModFix amt="15000"/>
+          </a:blip>
+          <a:stretch>
+            <a:fillRect/>
+          </a:stretch>
+        </p:blipFill>
+        <p:spPr>
+          <a:xfrm>
+            <a:off x="6126480" y="2125980"/>
+            <a:ext cx="2743200" cy="2743200"/>
+          </a:xfrm>
+          <a:prstGeom prst="rect">
+            <a:avLst/>
+          </a:prstGeom>
+        </p:spPr>
+      </p:pic>
+      <p:pic>
+        <p:nvPicPr>
+          <p:cNvPr id="64" name="Picture 63" descr="LOGO ISI CLARO.png"/>
+          <p:cNvPicPr>
+            <a:picLocks noChangeAspect="1"/>
+          </p:cNvPicPr>
+          <p:nvPr/>
+        </p:nvPicPr>
+        <p:blipFill>
+          <a:blip r:embed="rId5"/>
           <a:stretch>
             <a:fillRect/>
           </a:stretch>
@@ -26210,7 +26444,7 @@
             </a:pathLst>
           </a:custGeom>
           <a:solidFill>
-            <a:srgbClr val="150047"/>
+            <a:srgbClr val="2A3EF4"/>
           </a:solidFill>
           <a:ln>
             <a:noFill/>
@@ -26320,7 +26554,7 @@
           </a:xfrm>
           <a:prstGeom prst="roundRect">
             <a:avLst>
-              <a:gd name="adj" fmla="val 4000"/>
+              <a:gd name="adj" fmla="val 8000"/>
             </a:avLst>
           </a:prstGeom>
           <a:noFill/>
@@ -26416,9 +26650,9 @@
                 <a:solidFill>
                   <a:srgbClr val="150047"/>
                 </a:solidFill>
-                <a:latin typeface="Syne ExtraBold"/>
-                <a:ea typeface="Syne ExtraBold"/>
-                <a:cs typeface="Syne ExtraBold"/>
+                <a:latin typeface="Syne Bold"/>
+                <a:ea typeface="Syne Bold"/>
+                <a:cs typeface="Syne Bold"/>
                 <a:sym typeface="Arial Black"/>
               </a:rPr>
               <a:t>Tres fuerzas que empujan la "E"</a:t>
@@ -26621,7 +26855,7 @@
           </a:xfrm>
           <a:prstGeom prst="roundRect">
             <a:avLst>
-              <a:gd name="adj" fmla="val 4000"/>
+              <a:gd name="adj" fmla="val 8000"/>
             </a:avLst>
           </a:prstGeom>
           <a:noFill/>
@@ -26686,7 +26920,7 @@
           </a:xfrm>
           <a:prstGeom prst="roundRect">
             <a:avLst>
-              <a:gd name="adj" fmla="val 4000"/>
+              <a:gd name="adj" fmla="val 8000"/>
             </a:avLst>
           </a:prstGeom>
           <a:noFill/>
@@ -26877,7 +27111,7 @@
             </a:pathLst>
           </a:custGeom>
           <a:solidFill>
-            <a:srgbClr val="95EBDA"/>
+            <a:srgbClr val="2A3EF4"/>
           </a:solidFill>
           <a:ln>
             <a:noFill/>
@@ -26924,7 +27158,7 @@
           </a:xfrm>
           <a:prstGeom prst="roundRect">
             <a:avLst>
-              <a:gd name="adj" fmla="val 4000"/>
+              <a:gd name="adj" fmla="val 8000"/>
             </a:avLst>
           </a:prstGeom>
           <a:noFill/>
@@ -26989,7 +27223,7 @@
           </a:xfrm>
           <a:prstGeom prst="roundRect">
             <a:avLst>
-              <a:gd name="adj" fmla="val 4000"/>
+              <a:gd name="adj" fmla="val 8000"/>
             </a:avLst>
           </a:prstGeom>
           <a:noFill/>
@@ -27227,7 +27461,7 @@
           </a:xfrm>
           <a:prstGeom prst="roundRect">
             <a:avLst>
-              <a:gd name="adj" fmla="val 4000"/>
+              <a:gd name="adj" fmla="val 8000"/>
             </a:avLst>
           </a:prstGeom>
           <a:noFill/>
@@ -27292,7 +27526,7 @@
           </a:xfrm>
           <a:prstGeom prst="roundRect">
             <a:avLst>
-              <a:gd name="adj" fmla="val 4000"/>
+              <a:gd name="adj" fmla="val 8000"/>
             </a:avLst>
           </a:prstGeom>
           <a:noFill/>
@@ -27449,7 +27683,7 @@
             </a:pathLst>
           </a:custGeom>
           <a:solidFill>
-            <a:srgbClr val="150047"/>
+            <a:srgbClr val="2A3EF4"/>
           </a:solidFill>
           <a:ln>
             <a:noFill/>
@@ -27559,7 +27793,7 @@
           </a:xfrm>
           <a:prstGeom prst="roundRect">
             <a:avLst>
-              <a:gd name="adj" fmla="val 4000"/>
+              <a:gd name="adj" fmla="val 8000"/>
             </a:avLst>
           </a:prstGeom>
           <a:noFill/>
@@ -27655,9 +27889,9 @@
                 <a:solidFill>
                   <a:srgbClr val="150047"/>
                 </a:solidFill>
-                <a:latin typeface="Syne ExtraBold"/>
-                <a:ea typeface="Syne ExtraBold"/>
-                <a:cs typeface="Syne ExtraBold"/>
+                <a:latin typeface="Syne Bold"/>
+                <a:ea typeface="Syne Bold"/>
+                <a:cs typeface="Syne Bold"/>
                 <a:sym typeface="Arial Black"/>
               </a:rPr>
               <a:t>El error más común</a:t>
@@ -27687,11 +27921,11 @@
           </a:xfrm>
           <a:prstGeom prst="roundRect">
             <a:avLst>
-              <a:gd name="adj" fmla="val 4000"/>
+              <a:gd name="adj" fmla="val 8000"/>
             </a:avLst>
           </a:prstGeom>
           <a:solidFill>
-            <a:srgbClr val="150047"/>
+            <a:srgbClr val="2A3EF4"/>
           </a:solidFill>
           <a:ln>
             <a:noFill/>
@@ -27745,7 +27979,7 @@
           </a:xfrm>
           <a:prstGeom prst="roundRect">
             <a:avLst>
-              <a:gd name="adj" fmla="val 4000"/>
+              <a:gd name="adj" fmla="val 8000"/>
             </a:avLst>
           </a:prstGeom>
           <a:noFill/>
@@ -27810,7 +28044,7 @@
           </a:xfrm>
           <a:prstGeom prst="roundRect">
             <a:avLst>
-              <a:gd name="adj" fmla="val 4000"/>
+              <a:gd name="adj" fmla="val 8000"/>
             </a:avLst>
           </a:prstGeom>
           <a:solidFill>
@@ -27904,7 +28138,7 @@
             </a:pathLst>
           </a:custGeom>
           <a:solidFill>
-            <a:srgbClr val="95EBDA"/>
+            <a:srgbClr val="2A3EF4"/>
           </a:solidFill>
           <a:ln>
             <a:noFill/>
@@ -27958,7 +28192,7 @@
           </a:xfrm>
           <a:prstGeom prst="roundRect">
             <a:avLst>
-              <a:gd name="adj" fmla="val 4000"/>
+              <a:gd name="adj" fmla="val 8000"/>
             </a:avLst>
           </a:prstGeom>
           <a:noFill/>
@@ -27980,7 +28214,7 @@
           </a:xfrm>
           <a:prstGeom prst="roundRect">
             <a:avLst>
-              <a:gd name="adj" fmla="val 4000"/>
+              <a:gd name="adj" fmla="val 8000"/>
             </a:avLst>
           </a:prstGeom>
           <a:noFill/>
@@ -28184,7 +28418,7 @@
           </a:xfrm>
           <a:prstGeom prst="roundRect">
             <a:avLst>
-              <a:gd name="adj" fmla="val 4000"/>
+              <a:gd name="adj" fmla="val 8000"/>
             </a:avLst>
           </a:prstGeom>
           <a:noFill/>
@@ -28217,9 +28451,9 @@
                 <a:solidFill>
                   <a:srgbClr val="95EBDA"/>
                 </a:solidFill>
-                <a:latin typeface="Syne ExtraBold"/>
-                <a:ea typeface="Syne ExtraBold"/>
-                <a:cs typeface="Syne ExtraBold"/>
+                <a:latin typeface="Syne Bold"/>
+                <a:ea typeface="Syne Bold"/>
+                <a:cs typeface="Syne Bold"/>
                 <a:sym typeface="Arial Black"/>
               </a:rPr>
               <a:t>02</a:t>
@@ -28249,7 +28483,7 @@
           </a:xfrm>
           <a:prstGeom prst="roundRect">
             <a:avLst>
-              <a:gd name="adj" fmla="val 4000"/>
+              <a:gd name="adj" fmla="val 8000"/>
             </a:avLst>
           </a:prstGeom>
           <a:noFill/>
@@ -28421,7 +28655,7 @@
           </a:xfrm>
           <a:prstGeom prst="roundRect">
             <a:avLst>
-              <a:gd name="adj" fmla="val 4000"/>
+              <a:gd name="adj" fmla="val 8000"/>
             </a:avLst>
           </a:prstGeom>
           <a:noFill/>
@@ -28432,14 +28666,40 @@
       </p:pic>
       <p:pic>
         <p:nvPicPr>
-          <p:cNvPr id="109" name="Picture 108" descr="LOGO ISI CLARO.png"/>
+          <p:cNvPr id="109" name="Picture 108" descr="logo_isi_WHITE.png"/>
           <p:cNvPicPr>
             <a:picLocks noChangeAspect="1"/>
           </p:cNvPicPr>
           <p:nvPr/>
         </p:nvPicPr>
         <p:blipFill>
-          <a:blip r:embed="rId4"/>
+          <a:blip r:embed="rId4">
+            <a:alphaModFix amt="15000"/>
+          </a:blip>
+          <a:stretch>
+            <a:fillRect/>
+          </a:stretch>
+        </p:blipFill>
+        <p:spPr>
+          <a:xfrm>
+            <a:off x="6126480" y="2125980"/>
+            <a:ext cx="2743200" cy="2743200"/>
+          </a:xfrm>
+          <a:prstGeom prst="rect">
+            <a:avLst/>
+          </a:prstGeom>
+        </p:spPr>
+      </p:pic>
+      <p:pic>
+        <p:nvPicPr>
+          <p:cNvPr id="110" name="Picture 109" descr="LOGO ISI CLARO.png"/>
+          <p:cNvPicPr>
+            <a:picLocks noChangeAspect="1"/>
+          </p:cNvPicPr>
+          <p:nvPr/>
+        </p:nvPicPr>
+        <p:blipFill>
+          <a:blip r:embed="rId5"/>
           <a:stretch>
             <a:fillRect/>
           </a:stretch>
@@ -28535,7 +28795,7 @@
             </a:pathLst>
           </a:custGeom>
           <a:solidFill>
-            <a:srgbClr val="150047"/>
+            <a:srgbClr val="2A3EF4"/>
           </a:solidFill>
           <a:ln>
             <a:noFill/>
@@ -28645,7 +28905,7 @@
           </a:xfrm>
           <a:prstGeom prst="roundRect">
             <a:avLst>
-              <a:gd name="adj" fmla="val 4000"/>
+              <a:gd name="adj" fmla="val 8000"/>
             </a:avLst>
           </a:prstGeom>
           <a:noFill/>
@@ -28741,9 +29001,9 @@
                 <a:solidFill>
                   <a:srgbClr val="150047"/>
                 </a:solidFill>
-                <a:latin typeface="Syne ExtraBold"/>
-                <a:ea typeface="Syne ExtraBold"/>
-                <a:cs typeface="Syne ExtraBold"/>
+                <a:latin typeface="Syne Bold"/>
+                <a:ea typeface="Syne Bold"/>
+                <a:cs typeface="Syne Bold"/>
                 <a:sym typeface="Arial Black"/>
               </a:rPr>
               <a:t>Las 5 preguntas clave</a:t>
@@ -28899,7 +29159,7 @@
             </a:pathLst>
           </a:custGeom>
           <a:solidFill>
-            <a:srgbClr val="95EBDA"/>
+            <a:srgbClr val="2A3EF4"/>
           </a:solidFill>
           <a:ln>
             <a:noFill/>
@@ -28953,7 +29213,7 @@
           </a:xfrm>
           <a:prstGeom prst="roundRect">
             <a:avLst>
-              <a:gd name="adj" fmla="val 4000"/>
+              <a:gd name="adj" fmla="val 8000"/>
             </a:avLst>
           </a:prstGeom>
           <a:noFill/>
@@ -28975,7 +29235,7 @@
           </a:xfrm>
           <a:prstGeom prst="roundRect">
             <a:avLst>
-              <a:gd name="adj" fmla="val 4000"/>
+              <a:gd name="adj" fmla="val 8000"/>
             </a:avLst>
           </a:prstGeom>
           <a:noFill/>
@@ -29040,7 +29300,7 @@
           </a:xfrm>
           <a:prstGeom prst="roundRect">
             <a:avLst>
-              <a:gd name="adj" fmla="val 4000"/>
+              <a:gd name="adj" fmla="val 8000"/>
             </a:avLst>
           </a:prstGeom>
           <a:noFill/>
@@ -29231,7 +29491,7 @@
             </a:pathLst>
           </a:custGeom>
           <a:solidFill>
-            <a:srgbClr val="95EBDA"/>
+            <a:srgbClr val="2A3EF4"/>
           </a:solidFill>
           <a:ln>
             <a:noFill/>
@@ -29285,7 +29545,7 @@
           </a:xfrm>
           <a:prstGeom prst="roundRect">
             <a:avLst>
-              <a:gd name="adj" fmla="val 4000"/>
+              <a:gd name="adj" fmla="val 8000"/>
             </a:avLst>
           </a:prstGeom>
           <a:noFill/>
@@ -29307,7 +29567,7 @@
           </a:xfrm>
           <a:prstGeom prst="roundRect">
             <a:avLst>
-              <a:gd name="adj" fmla="val 4000"/>
+              <a:gd name="adj" fmla="val 8000"/>
             </a:avLst>
           </a:prstGeom>
           <a:noFill/>
@@ -29372,7 +29632,7 @@
           </a:xfrm>
           <a:prstGeom prst="roundRect">
             <a:avLst>
-              <a:gd name="adj" fmla="val 4000"/>
+              <a:gd name="adj" fmla="val 8000"/>
             </a:avLst>
           </a:prstGeom>
           <a:noFill/>
@@ -29563,7 +29823,7 @@
             </a:pathLst>
           </a:custGeom>
           <a:solidFill>
-            <a:srgbClr val="95EBDA"/>
+            <a:srgbClr val="2A3EF4"/>
           </a:solidFill>
           <a:ln>
             <a:noFill/>
@@ -29617,7 +29877,7 @@
           </a:xfrm>
           <a:prstGeom prst="roundRect">
             <a:avLst>
-              <a:gd name="adj" fmla="val 4000"/>
+              <a:gd name="adj" fmla="val 8000"/>
             </a:avLst>
           </a:prstGeom>
           <a:noFill/>
@@ -29639,7 +29899,7 @@
           </a:xfrm>
           <a:prstGeom prst="roundRect">
             <a:avLst>
-              <a:gd name="adj" fmla="val 4000"/>
+              <a:gd name="adj" fmla="val 8000"/>
             </a:avLst>
           </a:prstGeom>
           <a:noFill/>
@@ -29704,7 +29964,7 @@
           </a:xfrm>
           <a:prstGeom prst="roundRect">
             <a:avLst>
-              <a:gd name="adj" fmla="val 4000"/>
+              <a:gd name="adj" fmla="val 8000"/>
             </a:avLst>
           </a:prstGeom>
           <a:noFill/>
@@ -29895,7 +30155,7 @@
             </a:pathLst>
           </a:custGeom>
           <a:solidFill>
-            <a:srgbClr val="95EBDA"/>
+            <a:srgbClr val="2A3EF4"/>
           </a:solidFill>
           <a:ln>
             <a:noFill/>
@@ -29949,7 +30209,7 @@
           </a:xfrm>
           <a:prstGeom prst="roundRect">
             <a:avLst>
-              <a:gd name="adj" fmla="val 4000"/>
+              <a:gd name="adj" fmla="val 8000"/>
             </a:avLst>
           </a:prstGeom>
           <a:noFill/>
@@ -29971,7 +30231,7 @@
           </a:xfrm>
           <a:prstGeom prst="roundRect">
             <a:avLst>
-              <a:gd name="adj" fmla="val 4000"/>
+              <a:gd name="adj" fmla="val 8000"/>
             </a:avLst>
           </a:prstGeom>
           <a:noFill/>
@@ -30036,7 +30296,7 @@
           </a:xfrm>
           <a:prstGeom prst="roundRect">
             <a:avLst>
-              <a:gd name="adj" fmla="val 4000"/>
+              <a:gd name="adj" fmla="val 8000"/>
             </a:avLst>
           </a:prstGeom>
           <a:noFill/>
@@ -30227,7 +30487,7 @@
             </a:pathLst>
           </a:custGeom>
           <a:solidFill>
-            <a:srgbClr val="95EBDA"/>
+            <a:srgbClr val="2A3EF4"/>
           </a:solidFill>
           <a:ln>
             <a:noFill/>
@@ -30281,7 +30541,7 @@
           </a:xfrm>
           <a:prstGeom prst="roundRect">
             <a:avLst>
-              <a:gd name="adj" fmla="val 4000"/>
+              <a:gd name="adj" fmla="val 8000"/>
             </a:avLst>
           </a:prstGeom>
           <a:noFill/>
@@ -30303,7 +30563,7 @@
           </a:xfrm>
           <a:prstGeom prst="roundRect">
             <a:avLst>
-              <a:gd name="adj" fmla="val 4000"/>
+              <a:gd name="adj" fmla="val 8000"/>
             </a:avLst>
           </a:prstGeom>
           <a:noFill/>
@@ -30368,7 +30628,7 @@
           </a:xfrm>
           <a:prstGeom prst="roundRect">
             <a:avLst>
-              <a:gd name="adj" fmla="val 4000"/>
+              <a:gd name="adj" fmla="val 8000"/>
             </a:avLst>
           </a:prstGeom>
           <a:noFill/>
@@ -30635,7 +30895,7 @@
           </a:xfrm>
           <a:prstGeom prst="roundRect">
             <a:avLst>
-              <a:gd name="adj" fmla="val 4000"/>
+              <a:gd name="adj" fmla="val 8000"/>
             </a:avLst>
           </a:prstGeom>
           <a:noFill/>
@@ -30700,7 +30960,7 @@
           </a:xfrm>
           <a:prstGeom prst="roundRect">
             <a:avLst>
-              <a:gd name="adj" fmla="val 4000"/>
+              <a:gd name="adj" fmla="val 8000"/>
             </a:avLst>
           </a:prstGeom>
           <a:noFill/>
@@ -30733,9 +30993,9 @@
                 <a:solidFill>
                   <a:srgbClr val="95EBDA"/>
                 </a:solidFill>
-                <a:latin typeface="Syne ExtraBold"/>
-                <a:ea typeface="Syne ExtraBold"/>
-                <a:cs typeface="Syne ExtraBold"/>
+                <a:latin typeface="Syne Bold"/>
+                <a:ea typeface="Syne Bold"/>
+                <a:cs typeface="Syne Bold"/>
                 <a:sym typeface="Arial Black"/>
               </a:rPr>
               <a:t>80%</a:t>
@@ -30765,7 +31025,7 @@
           </a:xfrm>
           <a:prstGeom prst="roundRect">
             <a:avLst>
-              <a:gd name="adj" fmla="val 4000"/>
+              <a:gd name="adj" fmla="val 8000"/>
             </a:avLst>
           </a:prstGeom>
           <a:noFill/>
@@ -30913,7 +31173,7 @@
           </a:xfrm>
           <a:prstGeom prst="roundRect">
             <a:avLst>
-              <a:gd name="adj" fmla="val 4000"/>
+              <a:gd name="adj" fmla="val 8000"/>
             </a:avLst>
           </a:prstGeom>
           <a:noFill/>
@@ -31199,7 +31459,7 @@
           </a:xfrm>
           <a:prstGeom prst="roundRect">
             <a:avLst>
-              <a:gd name="adj" fmla="val 4000"/>
+              <a:gd name="adj" fmla="val 8000"/>
             </a:avLst>
           </a:prstGeom>
           <a:noFill/>
@@ -31232,9 +31492,9 @@
                 <a:solidFill>
                   <a:srgbClr val="95EBDA"/>
                 </a:solidFill>
-                <a:latin typeface="Syne ExtraBold"/>
-                <a:ea typeface="Syne ExtraBold"/>
-                <a:cs typeface="Syne ExtraBold"/>
+                <a:latin typeface="Syne Bold"/>
+                <a:ea typeface="Syne Bold"/>
+                <a:cs typeface="Syne Bold"/>
                 <a:sym typeface="Arial Black"/>
               </a:rPr>
               <a:t>03</a:t>
@@ -31264,7 +31524,7 @@
           </a:xfrm>
           <a:prstGeom prst="roundRect">
             <a:avLst>
-              <a:gd name="adj" fmla="val 4000"/>
+              <a:gd name="adj" fmla="val 8000"/>
             </a:avLst>
           </a:prstGeom>
           <a:noFill/>
@@ -31436,7 +31696,7 @@
           </a:xfrm>
           <a:prstGeom prst="roundRect">
             <a:avLst>
-              <a:gd name="adj" fmla="val 4000"/>
+              <a:gd name="adj" fmla="val 8000"/>
             </a:avLst>
           </a:prstGeom>
           <a:noFill/>
@@ -31447,14 +31707,40 @@
       </p:pic>
       <p:pic>
         <p:nvPicPr>
-          <p:cNvPr id="165" name="Picture 164" descr="LOGO ISI CLARO.png"/>
+          <p:cNvPr id="165" name="Picture 164" descr="logo_isi_WHITE.png"/>
           <p:cNvPicPr>
             <a:picLocks noChangeAspect="1"/>
           </p:cNvPicPr>
           <p:nvPr/>
         </p:nvPicPr>
         <p:blipFill>
-          <a:blip r:embed="rId4"/>
+          <a:blip r:embed="rId4">
+            <a:alphaModFix amt="15000"/>
+          </a:blip>
+          <a:stretch>
+            <a:fillRect/>
+          </a:stretch>
+        </p:blipFill>
+        <p:spPr>
+          <a:xfrm>
+            <a:off x="6126480" y="2125980"/>
+            <a:ext cx="2743200" cy="2743200"/>
+          </a:xfrm>
+          <a:prstGeom prst="rect">
+            <a:avLst/>
+          </a:prstGeom>
+        </p:spPr>
+      </p:pic>
+      <p:pic>
+        <p:nvPicPr>
+          <p:cNvPr id="166" name="Picture 165" descr="LOGO ISI CLARO.png"/>
+          <p:cNvPicPr>
+            <a:picLocks noChangeAspect="1"/>
+          </p:cNvPicPr>
+          <p:nvPr/>
+        </p:nvPicPr>
+        <p:blipFill>
+          <a:blip r:embed="rId5"/>
           <a:stretch>
             <a:fillRect/>
           </a:stretch>

</xml_diff>